<commit_message>
fig: overview C1 -> clean comparison table; drop page screenshot, CJK text, bottom bar
Per feedback: the same-page parse contrast (real page thumbnail + raw
garbled-CJK vs Korean text) read as confusing. Replace C1's second panel
with a clean 4-col comparison table (parser | Boundary Clarity | answer |
retrieval): MinerU 0.72(highest)/no/MISS vs Prod lower/yes/HIT, + 'appearance
metrics measure formatting, not content; r=-0.81'. Removes all CJK text and
the page screenshot. Also drop the bottom 'The parser...' takeaway line
(thesis lives in the caption). No Korean font needed anymore; slide trimmed
to 5.7in.
</commit_message>
<xml_diff>
--- a/paper/figures/fig_overview.pptx
+++ b/paper/figures/fig_overview.pptx
@@ -7,7 +7,7 @@
   <p:sldIdLst>
     <p:sldId id="256" r:id="rId7"/>
   </p:sldIdLst>
-  <p:sldSz cx="12161520" cy="5760720" type="screen4x3"/>
+  <p:sldSz cx="12161520" cy="5212080" type="screen4x3"/>
   <p:notesSz cx="6858000" cy="9144000"/>
   <p:defaultTextStyle>
     <a:defPPr>
@@ -3630,7 +3630,7 @@
         <p:spPr>
           <a:xfrm>
             <a:off x="201168" y="1764792"/>
-            <a:ext cx="3761232" cy="3246120"/>
+            <a:ext cx="3761232" cy="3108960"/>
           </a:xfrm>
           <a:prstGeom prst="roundRect">
             <a:avLst>
@@ -3751,45 +3751,432 @@
                 <a:ea typeface="Calibri"/>
                 <a:cs typeface="Calibri"/>
               </a:rPr>
-              <a:t>Same page → two parses (appearance lies)</a:t>
-            </a:r>
-          </a:p>
-        </p:txBody>
-      </p:sp>
-      <p:pic>
-        <p:nvPicPr>
-          <p:cNvPr id="19" name="Picture 18" descr="page_0533.png"/>
-          <p:cNvPicPr>
-            <a:picLocks noChangeAspect="1"/>
-          </p:cNvPicPr>
+              <a:t>Cleaner-looking ≠ better retrieval</a:t>
+            </a:r>
+          </a:p>
+        </p:txBody>
+      </p:sp>
+      <p:graphicFrame>
+        <p:nvGraphicFramePr>
+          <p:cNvPr id="19" name="Table 18"/>
+          <p:cNvGraphicFramePr>
+            <a:graphicFrameLocks noGrp="1"/>
+          </p:cNvGraphicFramePr>
           <p:nvPr/>
-        </p:nvPicPr>
-        <p:blipFill>
-          <a:blip r:embed="rId6"/>
-          <a:stretch>
-            <a:fillRect/>
-          </a:stretch>
-        </p:blipFill>
-        <p:spPr>
-          <a:xfrm>
-            <a:off x="310896" y="2363489"/>
-            <a:ext cx="1325879" cy="1874989"/>
+        </p:nvGraphicFramePr>
+        <p:xfrm>
+          <a:off x="384048" y="2267712"/>
+          <a:ext cx="3395470" cy="1554480"/>
+        </p:xfrm>
+        <a:graphic>
+          <a:graphicData uri="http://schemas.openxmlformats.org/drawingml/2006/table">
+            <a:tbl>
+              <a:tblPr>
+                <a:tableStyleId>{5C22544A-7EE6-4342-B048-85BDC9FD1C3A}</a:tableStyleId>
+              </a:tblPr>
+              <a:tblGrid>
+                <a:gridCol w="950732"/>
+                <a:gridCol w="1177096"/>
+                <a:gridCol w="561384"/>
+                <a:gridCol w="706258"/>
+              </a:tblGrid>
+              <a:tr h="518160">
+                <a:tc>
+                  <a:txBody>
+                    <a:bodyPr/>
+                    <a:lstStyle/>
+                    <a:p>
+                      <a:pPr algn="ctr"/>
+                      <a:r>
+                        <a:rPr sz="850" b="1">
+                          <a:solidFill>
+                            <a:srgbClr val="202020"/>
+                          </a:solidFill>
+                          <a:latin typeface="Calibri"/>
+                          <a:ea typeface="Calibri"/>
+                          <a:cs typeface="Calibri"/>
+                        </a:rPr>
+                        <a:t>parser</a:t>
+                      </a:r>
+                    </a:p>
+                  </a:txBody>
+                  <a:tcPr anchor="ctr" marL="38100" marR="38100" marT="12700" marB="12700">
+                    <a:solidFill>
+                      <a:srgbClr val="ECECEC"/>
+                    </a:solidFill>
+                  </a:tcPr>
+                </a:tc>
+                <a:tc>
+                  <a:txBody>
+                    <a:bodyPr/>
+                    <a:lstStyle/>
+                    <a:p>
+                      <a:pPr algn="ctr"/>
+                      <a:r>
+                        <a:rPr sz="850" b="1">
+                          <a:solidFill>
+                            <a:srgbClr val="202020"/>
+                          </a:solidFill>
+                          <a:latin typeface="Calibri"/>
+                          <a:ea typeface="Calibri"/>
+                          <a:cs typeface="Calibri"/>
+                        </a:rPr>
+                        <a:t>Boundary Clarity</a:t>
+                      </a:r>
+                    </a:p>
+                  </a:txBody>
+                  <a:tcPr anchor="ctr" marL="38100" marR="38100" marT="12700" marB="12700">
+                    <a:solidFill>
+                      <a:srgbClr val="ECECEC"/>
+                    </a:solidFill>
+                  </a:tcPr>
+                </a:tc>
+                <a:tc>
+                  <a:txBody>
+                    <a:bodyPr/>
+                    <a:lstStyle/>
+                    <a:p>
+                      <a:pPr algn="ctr"/>
+                      <a:r>
+                        <a:rPr sz="850" b="1">
+                          <a:solidFill>
+                            <a:srgbClr val="202020"/>
+                          </a:solidFill>
+                          <a:latin typeface="Calibri"/>
+                          <a:ea typeface="Calibri"/>
+                          <a:cs typeface="Calibri"/>
+                        </a:rPr>
+                        <a:t>answer</a:t>
+                      </a:r>
+                    </a:p>
+                  </a:txBody>
+                  <a:tcPr anchor="ctr" marL="38100" marR="38100" marT="12700" marB="12700">
+                    <a:solidFill>
+                      <a:srgbClr val="ECECEC"/>
+                    </a:solidFill>
+                  </a:tcPr>
+                </a:tc>
+                <a:tc>
+                  <a:txBody>
+                    <a:bodyPr/>
+                    <a:lstStyle/>
+                    <a:p>
+                      <a:pPr algn="ctr"/>
+                      <a:r>
+                        <a:rPr sz="850" b="1">
+                          <a:solidFill>
+                            <a:srgbClr val="202020"/>
+                          </a:solidFill>
+                          <a:latin typeface="Calibri"/>
+                          <a:ea typeface="Calibri"/>
+                          <a:cs typeface="Calibri"/>
+                        </a:rPr>
+                        <a:t>retrieval</a:t>
+                      </a:r>
+                    </a:p>
+                  </a:txBody>
+                  <a:tcPr anchor="ctr" marL="38100" marR="38100" marT="12700" marB="12700">
+                    <a:solidFill>
+                      <a:srgbClr val="ECECEC"/>
+                    </a:solidFill>
+                  </a:tcPr>
+                </a:tc>
+              </a:tr>
+              <a:tr h="518160">
+                <a:tc>
+                  <a:txBody>
+                    <a:bodyPr/>
+                    <a:lstStyle/>
+                    <a:p>
+                      <a:pPr algn="ctr"/>
+                      <a:r>
+                        <a:rPr sz="950" b="1">
+                          <a:solidFill>
+                            <a:srgbClr val="202020"/>
+                          </a:solidFill>
+                          <a:latin typeface="Calibri"/>
+                          <a:ea typeface="Calibri"/>
+                          <a:cs typeface="Calibri"/>
+                        </a:rPr>
+                        <a:t>MinerU</a:t>
+                      </a:r>
+                    </a:p>
+                  </a:txBody>
+                  <a:tcPr anchor="ctr" marL="38100" marR="38100" marT="12700" marB="12700">
+                    <a:solidFill>
+                      <a:srgbClr val="F9ECEC"/>
+                    </a:solidFill>
+                  </a:tcPr>
+                </a:tc>
+                <a:tc>
+                  <a:txBody>
+                    <a:bodyPr/>
+                    <a:lstStyle/>
+                    <a:p>
+                      <a:pPr algn="ctr"/>
+                      <a:r>
+                        <a:rPr sz="950" b="0">
+                          <a:solidFill>
+                            <a:srgbClr val="202020"/>
+                          </a:solidFill>
+                          <a:latin typeface="Calibri"/>
+                          <a:ea typeface="Calibri"/>
+                          <a:cs typeface="Calibri"/>
+                        </a:rPr>
+                        <a:t>0.72  (highest)</a:t>
+                      </a:r>
+                    </a:p>
+                  </a:txBody>
+                  <a:tcPr anchor="ctr" marL="38100" marR="38100" marT="12700" marB="12700">
+                    <a:solidFill>
+                      <a:srgbClr val="F9ECEC"/>
+                    </a:solidFill>
+                  </a:tcPr>
+                </a:tc>
+                <a:tc>
+                  <a:txBody>
+                    <a:bodyPr/>
+                    <a:lstStyle/>
+                    <a:p>
+                      <a:pPr algn="ctr"/>
+                      <a:r>
+                        <a:rPr sz="950" b="1">
+                          <a:solidFill>
+                            <a:srgbClr val="8F1B1B"/>
+                          </a:solidFill>
+                          <a:latin typeface="Calibri"/>
+                          <a:ea typeface="Calibri"/>
+                          <a:cs typeface="Calibri"/>
+                        </a:rPr>
+                        <a:t>no</a:t>
+                      </a:r>
+                    </a:p>
+                  </a:txBody>
+                  <a:tcPr anchor="ctr" marL="38100" marR="38100" marT="12700" marB="12700">
+                    <a:solidFill>
+                      <a:srgbClr val="F9ECEC"/>
+                    </a:solidFill>
+                  </a:tcPr>
+                </a:tc>
+                <a:tc>
+                  <a:txBody>
+                    <a:bodyPr/>
+                    <a:lstStyle/>
+                    <a:p>
+                      <a:pPr algn="ctr"/>
+                      <a:r>
+                        <a:rPr sz="950" b="1">
+                          <a:solidFill>
+                            <a:srgbClr val="8F1B1B"/>
+                          </a:solidFill>
+                          <a:latin typeface="Calibri"/>
+                          <a:ea typeface="Calibri"/>
+                          <a:cs typeface="Calibri"/>
+                        </a:rPr>
+                        <a:t>MISS</a:t>
+                      </a:r>
+                    </a:p>
+                  </a:txBody>
+                  <a:tcPr anchor="ctr" marL="38100" marR="38100" marT="12700" marB="12700">
+                    <a:solidFill>
+                      <a:srgbClr val="F9ECEC"/>
+                    </a:solidFill>
+                  </a:tcPr>
+                </a:tc>
+              </a:tr>
+              <a:tr h="518160">
+                <a:tc>
+                  <a:txBody>
+                    <a:bodyPr/>
+                    <a:lstStyle/>
+                    <a:p>
+                      <a:pPr algn="ctr"/>
+                      <a:r>
+                        <a:rPr sz="950" b="1">
+                          <a:solidFill>
+                            <a:srgbClr val="202020"/>
+                          </a:solidFill>
+                          <a:latin typeface="Calibri"/>
+                          <a:ea typeface="Calibri"/>
+                          <a:cs typeface="Calibri"/>
+                        </a:rPr>
+                        <a:t>Prod (ours)</a:t>
+                      </a:r>
+                    </a:p>
+                  </a:txBody>
+                  <a:tcPr anchor="ctr" marL="38100" marR="38100" marT="12700" marB="12700">
+                    <a:solidFill>
+                      <a:srgbClr val="ECF6EC"/>
+                    </a:solidFill>
+                  </a:tcPr>
+                </a:tc>
+                <a:tc>
+                  <a:txBody>
+                    <a:bodyPr/>
+                    <a:lstStyle/>
+                    <a:p>
+                      <a:pPr algn="ctr"/>
+                      <a:r>
+                        <a:rPr sz="950" b="0">
+                          <a:solidFill>
+                            <a:srgbClr val="202020"/>
+                          </a:solidFill>
+                          <a:latin typeface="Calibri"/>
+                          <a:ea typeface="Calibri"/>
+                          <a:cs typeface="Calibri"/>
+                        </a:rPr>
+                        <a:t>lower</a:t>
+                      </a:r>
+                    </a:p>
+                  </a:txBody>
+                  <a:tcPr anchor="ctr" marL="38100" marR="38100" marT="12700" marB="12700">
+                    <a:solidFill>
+                      <a:srgbClr val="ECF6EC"/>
+                    </a:solidFill>
+                  </a:tcPr>
+                </a:tc>
+                <a:tc>
+                  <a:txBody>
+                    <a:bodyPr/>
+                    <a:lstStyle/>
+                    <a:p>
+                      <a:pPr algn="ctr"/>
+                      <a:r>
+                        <a:rPr sz="950" b="1">
+                          <a:solidFill>
+                            <a:srgbClr val="1A6B1A"/>
+                          </a:solidFill>
+                          <a:latin typeface="Calibri"/>
+                          <a:ea typeface="Calibri"/>
+                          <a:cs typeface="Calibri"/>
+                        </a:rPr>
+                        <a:t>yes</a:t>
+                      </a:r>
+                    </a:p>
+                  </a:txBody>
+                  <a:tcPr anchor="ctr" marL="38100" marR="38100" marT="12700" marB="12700">
+                    <a:solidFill>
+                      <a:srgbClr val="ECF6EC"/>
+                    </a:solidFill>
+                  </a:tcPr>
+                </a:tc>
+                <a:tc>
+                  <a:txBody>
+                    <a:bodyPr/>
+                    <a:lstStyle/>
+                    <a:p>
+                      <a:pPr algn="ctr"/>
+                      <a:r>
+                        <a:rPr sz="950" b="1">
+                          <a:solidFill>
+                            <a:srgbClr val="1A6B1A"/>
+                          </a:solidFill>
+                          <a:latin typeface="Calibri"/>
+                          <a:ea typeface="Calibri"/>
+                          <a:cs typeface="Calibri"/>
+                        </a:rPr>
+                        <a:t>HIT</a:t>
+                      </a:r>
+                    </a:p>
+                  </a:txBody>
+                  <a:tcPr anchor="ctr" marL="38100" marR="38100" marT="12700" marB="12700">
+                    <a:solidFill>
+                      <a:srgbClr val="ECF6EC"/>
+                    </a:solidFill>
+                  </a:tcPr>
+                </a:tc>
+              </a:tr>
+            </a:tbl>
+          </a:graphicData>
+        </a:graphic>
+      </p:graphicFrame>
+      <p:sp>
+        <p:nvSpPr>
+          <p:cNvPr id="20" name="TextBox 19"/>
+          <p:cNvSpPr txBox="1"/>
+          <p:nvPr/>
+        </p:nvSpPr>
+        <p:spPr>
+          <a:xfrm>
+            <a:off x="329184" y="3959352"/>
+            <a:ext cx="3505200" cy="822960"/>
           </a:xfrm>
           <a:prstGeom prst="rect">
             <a:avLst/>
           </a:prstGeom>
-        </p:spPr>
-      </p:pic>
-      <p:sp>
-        <p:nvSpPr>
-          <p:cNvPr id="20" name="Rounded Rectangle 19"/>
+          <a:noFill/>
+        </p:spPr>
+        <p:txBody>
+          <a:bodyPr wrap="square" anchor="t" lIns="38100" rIns="38100" tIns="25400" bIns="25400">
+            <a:spAutoFit/>
+          </a:bodyPr>
+          <a:lstStyle/>
+          <a:p>
+            <a:pPr algn="ctr">
+              <a:lnSpc>
+                <a:spcPct val="132000"/>
+              </a:lnSpc>
+            </a:pPr>
+            <a:r>
+              <a:rPr sz="950" b="0" i="0">
+                <a:solidFill>
+                  <a:srgbClr val="202020"/>
+                </a:solidFill>
+                <a:latin typeface="Calibri"/>
+                <a:ea typeface="Calibri"/>
+                <a:cs typeface="Calibri"/>
+              </a:rPr>
+              <a:t>highest Boundary Clarity, yet worst retrieval:</a:t>
+            </a:r>
+          </a:p>
+          <a:p>
+            <a:pPr algn="ctr">
+              <a:lnSpc>
+                <a:spcPct val="132000"/>
+              </a:lnSpc>
+            </a:pPr>
+            <a:r>
+              <a:rPr sz="950" b="0" i="0">
+                <a:solidFill>
+                  <a:srgbClr val="202020"/>
+                </a:solidFill>
+                <a:latin typeface="Calibri"/>
+                <a:ea typeface="Calibri"/>
+                <a:cs typeface="Calibri"/>
+              </a:rPr>
+              <a:t>appearance metrics measure formatting, not content</a:t>
+            </a:r>
+          </a:p>
+          <a:p>
+            <a:pPr algn="ctr">
+              <a:lnSpc>
+                <a:spcPct val="132000"/>
+              </a:lnSpc>
+            </a:pPr>
+            <a:r>
+              <a:rPr sz="1050" b="1" i="0">
+                <a:solidFill>
+                  <a:srgbClr val="8F1B1B"/>
+                </a:solidFill>
+                <a:latin typeface="Calibri"/>
+                <a:ea typeface="Calibri"/>
+                <a:cs typeface="Calibri"/>
+              </a:rPr>
+              <a:t>anti-correlation   r = −0.81</a:t>
+            </a:r>
+          </a:p>
+        </p:txBody>
+      </p:sp>
+      <p:sp>
+        <p:nvSpPr>
+          <p:cNvPr id="21" name="Rounded Rectangle 20"/>
           <p:cNvSpPr/>
           <p:nvPr/>
         </p:nvSpPr>
         <p:spPr>
           <a:xfrm>
-            <a:off x="1773936" y="2240280"/>
-            <a:ext cx="2060448" cy="969264"/>
+            <a:off x="4200144" y="749808"/>
+            <a:ext cx="3761232" cy="2331720"/>
           </a:xfrm>
           <a:prstGeom prst="roundRect">
             <a:avLst>
@@ -3797,11 +4184,11 @@
             </a:avLst>
           </a:prstGeom>
           <a:solidFill>
-            <a:srgbClr val="F9ECEC"/>
+            <a:srgbClr val="FFFFFF"/>
           </a:solidFill>
-          <a:ln w="13970">
+          <a:ln w="15875">
             <a:solidFill>
-              <a:srgbClr val="8F1B1B"/>
+              <a:srgbClr val="9A5A00"/>
             </a:solidFill>
           </a:ln>
           <a:effectLst/>
@@ -3830,115 +4217,25 @@
       </p:sp>
       <p:sp>
         <p:nvSpPr>
-          <p:cNvPr id="21" name="TextBox 20"/>
-          <p:cNvSpPr txBox="1"/>
-          <p:nvPr/>
-        </p:nvSpPr>
-        <p:spPr>
-          <a:xfrm>
-            <a:off x="1856231" y="2240280"/>
-            <a:ext cx="1895856" cy="969264"/>
-          </a:xfrm>
-          <a:prstGeom prst="rect">
-            <a:avLst/>
-          </a:prstGeom>
-          <a:noFill/>
-        </p:spPr>
-        <p:txBody>
-          <a:bodyPr wrap="square" anchor="ctr" lIns="38100" rIns="38100" tIns="25400" bIns="25400">
-            <a:spAutoFit/>
-          </a:bodyPr>
-          <a:lstStyle/>
-          <a:p>
-            <a:pPr algn="l">
-              <a:lnSpc>
-                <a:spcPct val="118000"/>
-              </a:lnSpc>
-            </a:pPr>
-            <a:r>
-              <a:rPr sz="950" b="1" i="0">
-                <a:solidFill>
-                  <a:srgbClr val="8F1B1B"/>
-                </a:solidFill>
-                <a:latin typeface="Calibri"/>
-                <a:ea typeface="Calibri"/>
-                <a:cs typeface="Calibri"/>
-              </a:rPr>
-              <a:t>MinerU — BC 0.72 (cleanest)</a:t>
-            </a:r>
-          </a:p>
-          <a:p>
-            <a:pPr algn="l">
-              <a:lnSpc>
-                <a:spcPct val="118000"/>
-              </a:lnSpc>
-            </a:pPr>
-            <a:r>
-              <a:rPr sz="900" b="0" i="0">
-                <a:solidFill>
-                  <a:srgbClr val="202020"/>
-                </a:solidFill>
-                <a:latin typeface="Noto Sans CJK KR"/>
-                <a:ea typeface="Noto Sans CJK KR"/>
-                <a:cs typeface="Noto Sans CJK KR"/>
-              </a:rPr>
-              <a:t>(2) 即个张号 Sand Mat音斗个张叶</a:t>
-            </a:r>
-          </a:p>
-          <a:p>
-            <a:pPr algn="l">
-              <a:lnSpc>
-                <a:spcPct val="118000"/>
-              </a:lnSpc>
-            </a:pPr>
-            <a:r>
-              <a:rPr sz="850" b="0" i="1">
-                <a:solidFill>
-                  <a:srgbClr val="555555"/>
-                </a:solidFill>
-                <a:latin typeface="Calibri"/>
-                <a:ea typeface="Calibri"/>
-                <a:cs typeface="Calibri"/>
-              </a:rPr>
-              <a:t>clean structure, garbled text</a:t>
-            </a:r>
-            <a:r>
-              <a:rPr sz="950" b="1" i="0">
-                <a:solidFill>
-                  <a:srgbClr val="8F1B1B"/>
-                </a:solidFill>
-                <a:latin typeface="Calibri"/>
-                <a:ea typeface="Calibri"/>
-                <a:cs typeface="Calibri"/>
-              </a:rPr>
-              <a:t>   MISS</a:t>
-            </a:r>
-          </a:p>
-        </p:txBody>
-      </p:sp>
-      <p:sp>
-        <p:nvSpPr>
           <p:cNvPr id="22" name="Rounded Rectangle 21"/>
           <p:cNvSpPr/>
           <p:nvPr/>
         </p:nvSpPr>
         <p:spPr>
           <a:xfrm>
-            <a:off x="1773936" y="3337560"/>
-            <a:ext cx="2060448" cy="969264"/>
+            <a:off x="4200144" y="749808"/>
+            <a:ext cx="3761232" cy="310896"/>
           </a:xfrm>
           <a:prstGeom prst="roundRect">
             <a:avLst>
-              <a:gd name="adj" fmla="val 4000"/>
+              <a:gd name="adj" fmla="val 10000"/>
             </a:avLst>
           </a:prstGeom>
           <a:solidFill>
-            <a:srgbClr val="ECF6EC"/>
+            <a:srgbClr val="FCF3E6"/>
           </a:solidFill>
-          <a:ln w="13970">
-            <a:solidFill>
-              <a:srgbClr val="1A6B1A"/>
-            </a:solidFill>
+          <a:ln>
+            <a:noFill/>
           </a:ln>
           <a:effectLst/>
         </p:spPr>
@@ -3972,8 +4269,8 @@
         </p:nvSpPr>
         <p:spPr>
           <a:xfrm>
-            <a:off x="1856231" y="3337560"/>
-            <a:ext cx="1895856" cy="969264"/>
+            <a:off x="4245864" y="749808"/>
+            <a:ext cx="3669792" cy="310896"/>
           </a:xfrm>
           <a:prstGeom prst="rect">
             <a:avLst/>
@@ -3988,80 +4285,57 @@
           <a:p>
             <a:pPr algn="l">
               <a:lnSpc>
-                <a:spcPct val="118000"/>
+                <a:spcPct val="110000"/>
               </a:lnSpc>
             </a:pPr>
             <a:r>
-              <a:rPr sz="950" b="1" i="0">
+              <a:rPr sz="1050" b="1" i="0">
                 <a:solidFill>
-                  <a:srgbClr val="1A6B1A"/>
+                  <a:srgbClr val="9A5A00"/>
                 </a:solidFill>
                 <a:latin typeface="Calibri"/>
                 <a:ea typeface="Calibri"/>
                 <a:cs typeface="Calibri"/>
               </a:rPr>
-              <a:t>Prod (Qwen3-VL-2B) — lower BC</a:t>
-            </a:r>
-          </a:p>
-          <a:p>
-            <a:pPr algn="l">
-              <a:lnSpc>
-                <a:spcPct val="118000"/>
-              </a:lnSpc>
-            </a:pPr>
-            <a:r>
-              <a:rPr sz="900" b="0" i="0">
-                <a:solidFill>
-                  <a:srgbClr val="202020"/>
-                </a:solidFill>
-                <a:latin typeface="Noto Sans CJK KR"/>
-                <a:ea typeface="Noto Sans CJK KR"/>
-                <a:cs typeface="Noto Sans CJK KR"/>
-              </a:rPr>
-              <a:t>모래수량은 Sand Mat층을 제외한 수량</a:t>
-            </a:r>
-          </a:p>
-          <a:p>
-            <a:pPr algn="l">
-              <a:lnSpc>
-                <a:spcPct val="118000"/>
-              </a:lnSpc>
-            </a:pPr>
-            <a:r>
-              <a:rPr sz="850" b="0" i="1">
-                <a:solidFill>
-                  <a:srgbClr val="555555"/>
-                </a:solidFill>
-                <a:latin typeface="Calibri"/>
-                <a:ea typeface="Calibri"/>
-                <a:cs typeface="Calibri"/>
-              </a:rPr>
-              <a:t>messier metric, answer kept</a:t>
-            </a:r>
-            <a:r>
-              <a:rPr sz="950" b="1" i="0">
-                <a:solidFill>
-                  <a:srgbClr val="1A6B1A"/>
-                </a:solidFill>
-                <a:latin typeface="Calibri"/>
-                <a:ea typeface="Calibri"/>
-                <a:cs typeface="Calibri"/>
-              </a:rPr>
-              <a:t>   HIT</a:t>
-            </a:r>
-          </a:p>
-        </p:txBody>
-      </p:sp>
-      <p:sp>
-        <p:nvSpPr>
-          <p:cNvPr id="24" name="TextBox 23"/>
+              <a:t>C2 · Coverage diagnostic (no retriever)</a:t>
+            </a:r>
+          </a:p>
+        </p:txBody>
+      </p:sp>
+      <p:pic>
+        <p:nvPicPr>
+          <p:cNvPr id="24" name="Picture 23" descr="fig_coverage.png"/>
+          <p:cNvPicPr>
+            <a:picLocks noChangeAspect="1"/>
+          </p:cNvPicPr>
+          <p:nvPr/>
+        </p:nvPicPr>
+        <p:blipFill>
+          <a:blip r:embed="rId6"/>
+          <a:stretch>
+            <a:fillRect/>
+          </a:stretch>
+        </p:blipFill>
+        <p:spPr>
+          <a:xfrm>
+            <a:off x="4800833" y="1115568"/>
+            <a:ext cx="2559852" cy="1417319"/>
+          </a:xfrm>
+          <a:prstGeom prst="rect">
+            <a:avLst/>
+          </a:prstGeom>
+        </p:spPr>
+      </p:pic>
+      <p:sp>
+        <p:nvSpPr>
+          <p:cNvPr id="25" name="TextBox 24"/>
           <p:cNvSpPr txBox="1"/>
           <p:nvPr/>
         </p:nvSpPr>
         <p:spPr>
           <a:xfrm>
-            <a:off x="310896" y="4553712"/>
-            <a:ext cx="3541776" cy="402336"/>
+            <a:off x="4309872" y="2532887"/>
+            <a:ext cx="3541776" cy="502920"/>
           </a:xfrm>
           <a:prstGeom prst="rect">
             <a:avLst/>
@@ -4069,7 +4343,7 @@
           <a:noFill/>
         </p:spPr>
         <p:txBody>
-          <a:bodyPr wrap="square" anchor="ctr" lIns="38100" rIns="38100" tIns="25400" bIns="25400">
+          <a:bodyPr wrap="square" anchor="t" lIns="38100" rIns="38100" tIns="25400" bIns="25400">
             <a:spAutoFit/>
           </a:bodyPr>
           <a:lstStyle/>
@@ -4079,17 +4353,6 @@
                 <a:spcPct val="110000"/>
               </a:lnSpc>
             </a:pPr>
-            <a:r>
-              <a:rPr sz="950" b="0" i="0">
-                <a:solidFill>
-                  <a:srgbClr val="202020"/>
-                </a:solidFill>
-                <a:latin typeface="Calibri"/>
-                <a:ea typeface="Calibri"/>
-                <a:cs typeface="Calibri"/>
-              </a:rPr>
-              <a:t>cleanest-looking parse retrieves worst — </a:t>
-            </a:r>
             <a:r>
               <a:rPr sz="1050" b="1" i="0">
                 <a:solidFill>
@@ -4099,21 +4362,39 @@
                 <a:ea typeface="Calibri"/>
                 <a:cs typeface="Calibri"/>
               </a:rPr>
-              <a:t>r = −0.81</a:t>
-            </a:r>
-          </a:p>
-        </p:txBody>
-      </p:sp>
-      <p:sp>
-        <p:nvSpPr>
-          <p:cNvPr id="25" name="Rounded Rectangle 24"/>
+              <a:t>20.2% of answers absent = parser fault</a:t>
+            </a:r>
+          </a:p>
+          <a:p>
+            <a:pPr algn="ctr">
+              <a:lnSpc>
+                <a:spcPct val="110000"/>
+              </a:lnSpc>
+            </a:pPr>
+            <a:r>
+              <a:rPr sz="880" b="0" i="1">
+                <a:solidFill>
+                  <a:srgbClr val="555555"/>
+                </a:solidFill>
+                <a:latin typeface="Calibri"/>
+                <a:ea typeface="Calibri"/>
+                <a:cs typeface="Calibri"/>
+              </a:rPr>
+              <a:t>flat across 8 chunkers → fix the parser, not the chunker</a:t>
+            </a:r>
+          </a:p>
+        </p:txBody>
+      </p:sp>
+      <p:sp>
+        <p:nvSpPr>
+          <p:cNvPr id="26" name="Rounded Rectangle 25"/>
           <p:cNvSpPr/>
           <p:nvPr/>
         </p:nvSpPr>
         <p:spPr>
           <a:xfrm>
-            <a:off x="4200144" y="749808"/>
-            <a:ext cx="3761232" cy="2331720"/>
+            <a:off x="4200144" y="3227832"/>
+            <a:ext cx="3761232" cy="1691640"/>
           </a:xfrm>
           <a:prstGeom prst="roundRect">
             <a:avLst>
@@ -4154,13 +4435,13 @@
       </p:sp>
       <p:sp>
         <p:nvSpPr>
-          <p:cNvPr id="26" name="Rounded Rectangle 25"/>
+          <p:cNvPr id="27" name="Rounded Rectangle 26"/>
           <p:cNvSpPr/>
           <p:nvPr/>
         </p:nvSpPr>
         <p:spPr>
           <a:xfrm>
-            <a:off x="4200144" y="749808"/>
+            <a:off x="4200144" y="3227832"/>
             <a:ext cx="3761232" cy="310896"/>
           </a:xfrm>
           <a:prstGeom prst="roundRect">
@@ -4200,13 +4481,13 @@
       </p:sp>
       <p:sp>
         <p:nvSpPr>
-          <p:cNvPr id="27" name="TextBox 26"/>
+          <p:cNvPr id="28" name="TextBox 27"/>
           <p:cNvSpPr txBox="1"/>
           <p:nvPr/>
         </p:nvSpPr>
         <p:spPr>
           <a:xfrm>
-            <a:off x="4245864" y="749808"/>
+            <a:off x="4245864" y="3227832"/>
             <a:ext cx="3669792" cy="310896"/>
           </a:xfrm>
           <a:prstGeom prst="rect">
@@ -4234,14 +4515,55 @@
                 <a:ea typeface="Calibri"/>
                 <a:cs typeface="Calibri"/>
               </a:rPr>
-              <a:t>C2 · Coverage diagnostic (no retriever)</a:t>
+              <a:t>C3 · RCPS selection protocol (no training)</a:t>
+            </a:r>
+          </a:p>
+        </p:txBody>
+      </p:sp>
+      <p:sp>
+        <p:nvSpPr>
+          <p:cNvPr id="29" name="TextBox 28"/>
+          <p:cNvSpPr txBox="1"/>
+          <p:nvPr/>
+        </p:nvSpPr>
+        <p:spPr>
+          <a:xfrm>
+            <a:off x="4309872" y="3611879"/>
+            <a:ext cx="3541776" cy="365760"/>
+          </a:xfrm>
+          <a:prstGeom prst="rect">
+            <a:avLst/>
+          </a:prstGeom>
+          <a:noFill/>
+        </p:spPr>
+        <p:txBody>
+          <a:bodyPr wrap="square" anchor="t" lIns="38100" rIns="38100" tIns="25400" bIns="25400">
+            <a:spAutoFit/>
+          </a:bodyPr>
+          <a:lstStyle/>
+          <a:p>
+            <a:pPr algn="l">
+              <a:lnSpc>
+                <a:spcPct val="110000"/>
+              </a:lnSpc>
+            </a:pPr>
+            <a:r>
+              <a:rPr sz="950" b="0" i="0">
+                <a:solidFill>
+                  <a:srgbClr val="202020"/>
+                </a:solidFill>
+                <a:latin typeface="Calibri"/>
+                <a:ea typeface="Calibri"/>
+                <a:cs typeface="Calibri"/>
+              </a:rPr>
+              <a:t>held-out Q–A probe, scored over 3 retrievers:</a:t>
             </a:r>
           </a:p>
         </p:txBody>
       </p:sp>
       <p:pic>
         <p:nvPicPr>
-          <p:cNvPr id="28" name="Picture 27" descr="fig_coverage.png"/>
+          <p:cNvPr id="30" name="Picture 29" descr="bge_baai.png"/>
           <p:cNvPicPr>
             <a:picLocks noChangeAspect="1"/>
           </p:cNvPicPr>
@@ -4255,24 +4577,72 @@
         </p:blipFill>
         <p:spPr>
           <a:xfrm>
-            <a:off x="4800833" y="1115568"/>
-            <a:ext cx="2559852" cy="1417319"/>
+            <a:off x="4840224" y="3977639"/>
+            <a:ext cx="457200" cy="457200"/>
           </a:xfrm>
           <a:prstGeom prst="rect">
             <a:avLst/>
           </a:prstGeom>
         </p:spPr>
       </p:pic>
-      <p:sp>
-        <p:nvSpPr>
-          <p:cNvPr id="29" name="TextBox 28"/>
+      <p:pic>
+        <p:nvPicPr>
+          <p:cNvPr id="31" name="Picture 30" descr="me5_ms.png"/>
+          <p:cNvPicPr>
+            <a:picLocks noChangeAspect="1"/>
+          </p:cNvPicPr>
+          <p:nvPr/>
+        </p:nvPicPr>
+        <p:blipFill>
+          <a:blip r:embed="rId8"/>
+          <a:stretch>
+            <a:fillRect/>
+          </a:stretch>
+        </p:blipFill>
+        <p:spPr>
+          <a:xfrm>
+            <a:off x="5891784" y="3977639"/>
+            <a:ext cx="457200" cy="457200"/>
+          </a:xfrm>
+          <a:prstGeom prst="rect">
+            <a:avLst/>
+          </a:prstGeom>
+        </p:spPr>
+      </p:pic>
+      <p:pic>
+        <p:nvPicPr>
+          <p:cNvPr id="32" name="Picture 31" descr="qwen.png"/>
+          <p:cNvPicPr>
+            <a:picLocks noChangeAspect="1"/>
+          </p:cNvPicPr>
+          <p:nvPr/>
+        </p:nvPicPr>
+        <p:blipFill>
+          <a:blip r:embed="rId2"/>
+          <a:stretch>
+            <a:fillRect/>
+          </a:stretch>
+        </p:blipFill>
+        <p:spPr>
+          <a:xfrm>
+            <a:off x="6806184" y="3977639"/>
+            <a:ext cx="457200" cy="457200"/>
+          </a:xfrm>
+          <a:prstGeom prst="rect">
+            <a:avLst/>
+          </a:prstGeom>
+        </p:spPr>
+      </p:pic>
+      <p:sp>
+        <p:nvSpPr>
+          <p:cNvPr id="33" name="TextBox 32"/>
           <p:cNvSpPr txBox="1"/>
           <p:nvPr/>
         </p:nvSpPr>
         <p:spPr>
           <a:xfrm>
-            <a:off x="4309872" y="2532887"/>
-            <a:ext cx="3541776" cy="502920"/>
+            <a:off x="4291584" y="4453128"/>
+            <a:ext cx="3578352" cy="219456"/>
           </a:xfrm>
           <a:prstGeom prst="rect">
             <a:avLst/>
@@ -4291,25 +4661,7 @@
               </a:lnSpc>
             </a:pPr>
             <a:r>
-              <a:rPr sz="1050" b="1" i="0">
-                <a:solidFill>
-                  <a:srgbClr val="8F1B1B"/>
-                </a:solidFill>
-                <a:latin typeface="Calibri"/>
-                <a:ea typeface="Calibri"/>
-                <a:cs typeface="Calibri"/>
-              </a:rPr>
-              <a:t>20.2% of answers absent = parser fault</a:t>
-            </a:r>
-          </a:p>
-          <a:p>
-            <a:pPr algn="ctr">
-              <a:lnSpc>
-                <a:spcPct val="110000"/>
-              </a:lnSpc>
-            </a:pPr>
-            <a:r>
-              <a:rPr sz="880" b="0" i="1">
+              <a:rPr sz="850" b="0" i="1">
                 <a:solidFill>
                   <a:srgbClr val="555555"/>
                 </a:solidFill>
@@ -4317,21 +4669,62 @@
                 <a:ea typeface="Calibri"/>
                 <a:cs typeface="Calibri"/>
               </a:rPr>
-              <a:t>flat across 8 chunkers → fix the parser, not the chunker</a:t>
-            </a:r>
-          </a:p>
-        </p:txBody>
-      </p:sp>
-      <p:sp>
-        <p:nvSpPr>
-          <p:cNvPr id="30" name="Rounded Rectangle 29"/>
+              <a:t>BGE-M3 · mE5 · Qwen3-Emb</a:t>
+            </a:r>
+          </a:p>
+        </p:txBody>
+      </p:sp>
+      <p:sp>
+        <p:nvSpPr>
+          <p:cNvPr id="34" name="TextBox 33"/>
+          <p:cNvSpPr txBox="1"/>
+          <p:nvPr/>
+        </p:nvSpPr>
+        <p:spPr>
+          <a:xfrm>
+            <a:off x="4309872" y="4553712"/>
+            <a:ext cx="3541776" cy="310896"/>
+          </a:xfrm>
+          <a:prstGeom prst="rect">
+            <a:avLst/>
+          </a:prstGeom>
+          <a:noFill/>
+        </p:spPr>
+        <p:txBody>
+          <a:bodyPr wrap="square" anchor="t" lIns="38100" rIns="38100" tIns="25400" bIns="25400">
+            <a:spAutoFit/>
+          </a:bodyPr>
+          <a:lstStyle/>
+          <a:p>
+            <a:pPr algn="ctr">
+              <a:lnSpc>
+                <a:spcPct val="110000"/>
+              </a:lnSpc>
+            </a:pPr>
+            <a:r>
+              <a:rPr sz="1050" b="1" i="0">
+                <a:solidFill>
+                  <a:srgbClr val="9A5A00"/>
+                </a:solidFill>
+                <a:latin typeface="Calibri"/>
+                <a:ea typeface="Calibri"/>
+                <a:cs typeface="Calibri"/>
+              </a:rPr>
+              <a:t>→ rank parsers &amp; chunkers by retrieval</a:t>
+            </a:r>
+          </a:p>
+        </p:txBody>
+      </p:sp>
+      <p:sp>
+        <p:nvSpPr>
+          <p:cNvPr id="35" name="Rounded Rectangle 34"/>
           <p:cNvSpPr/>
           <p:nvPr/>
         </p:nvSpPr>
         <p:spPr>
           <a:xfrm>
-            <a:off x="4200144" y="3227832"/>
-            <a:ext cx="3761232" cy="1691640"/>
+            <a:off x="8199120" y="749808"/>
+            <a:ext cx="3761232" cy="1783080"/>
           </a:xfrm>
           <a:prstGeom prst="roundRect">
             <a:avLst>
@@ -4343,7 +4736,7 @@
           </a:solidFill>
           <a:ln w="15875">
             <a:solidFill>
-              <a:srgbClr val="9A5A00"/>
+              <a:srgbClr val="1A6B1A"/>
             </a:solidFill>
           </a:ln>
           <a:effectLst/>
@@ -4372,13 +4765,13 @@
       </p:sp>
       <p:sp>
         <p:nvSpPr>
-          <p:cNvPr id="31" name="Rounded Rectangle 30"/>
+          <p:cNvPr id="36" name="Rounded Rectangle 35"/>
           <p:cNvSpPr/>
           <p:nvPr/>
         </p:nvSpPr>
         <p:spPr>
           <a:xfrm>
-            <a:off x="4200144" y="3227832"/>
+            <a:off x="8199120" y="749808"/>
             <a:ext cx="3761232" cy="310896"/>
           </a:xfrm>
           <a:prstGeom prst="roundRect">
@@ -4387,7 +4780,7 @@
             </a:avLst>
           </a:prstGeom>
           <a:solidFill>
-            <a:srgbClr val="FCF3E6"/>
+            <a:srgbClr val="ECF6EC"/>
           </a:solidFill>
           <a:ln>
             <a:noFill/>
@@ -4418,13 +4811,13 @@
       </p:sp>
       <p:sp>
         <p:nvSpPr>
-          <p:cNvPr id="32" name="TextBox 31"/>
+          <p:cNvPr id="37" name="TextBox 36"/>
           <p:cNvSpPr txBox="1"/>
           <p:nvPr/>
         </p:nvSpPr>
         <p:spPr>
           <a:xfrm>
-            <a:off x="4245864" y="3227832"/>
+            <a:off x="8244840" y="749808"/>
             <a:ext cx="3669792" cy="310896"/>
           </a:xfrm>
           <a:prstGeom prst="rect">
@@ -4446,27 +4839,27 @@
             <a:r>
               <a:rPr sz="1050" b="1" i="0">
                 <a:solidFill>
-                  <a:srgbClr val="9A5A00"/>
+                  <a:srgbClr val="1A6B1A"/>
                 </a:solidFill>
                 <a:latin typeface="Calibri"/>
                 <a:ea typeface="Calibri"/>
                 <a:cs typeface="Calibri"/>
               </a:rPr>
-              <a:t>C3 · RCPS selection protocol (no training)</a:t>
-            </a:r>
-          </a:p>
-        </p:txBody>
-      </p:sp>
-      <p:sp>
-        <p:nvSpPr>
-          <p:cNvPr id="33" name="TextBox 32"/>
+              <a:t>C4 · Parser-side training</a:t>
+            </a:r>
+          </a:p>
+        </p:txBody>
+      </p:sp>
+      <p:sp>
+        <p:nvSpPr>
+          <p:cNvPr id="38" name="TextBox 37"/>
           <p:cNvSpPr txBox="1"/>
           <p:nvPr/>
         </p:nvSpPr>
         <p:spPr>
           <a:xfrm>
-            <a:off x="4309872" y="3611879"/>
-            <a:ext cx="3541776" cy="365760"/>
+            <a:off x="8327136" y="1152144"/>
+            <a:ext cx="3505200" cy="365760"/>
           </a:xfrm>
           <a:prstGeom prst="rect">
             <a:avLst/>
@@ -4493,93 +4886,110 @@
                 <a:ea typeface="Calibri"/>
                 <a:cs typeface="Calibri"/>
               </a:rPr>
-              <a:t>held-out Q–A probe, scored over 3 retrievers:</a:t>
-            </a:r>
-          </a:p>
-        </p:txBody>
-      </p:sp>
-      <p:pic>
-        <p:nvPicPr>
-          <p:cNvPr id="34" name="Picture 33" descr="bge_baai.png"/>
-          <p:cNvPicPr>
-            <a:picLocks noChangeAspect="1"/>
-          </p:cNvPicPr>
+              <a:t>best-of-K parses from Prod, ranked two ways:</a:t>
+            </a:r>
+          </a:p>
+        </p:txBody>
+      </p:sp>
+      <p:sp>
+        <p:nvSpPr>
+          <p:cNvPr id="39" name="Rounded Rectangle 38"/>
+          <p:cNvSpPr/>
           <p:nvPr/>
-        </p:nvPicPr>
-        <p:blipFill>
-          <a:blip r:embed="rId8"/>
-          <a:stretch>
-            <a:fillRect/>
-          </a:stretch>
-        </p:blipFill>
-        <p:spPr>
-          <a:xfrm>
-            <a:off x="4840224" y="3977639"/>
-            <a:ext cx="457200" cy="457200"/>
+        </p:nvSpPr>
+        <p:spPr>
+          <a:xfrm>
+            <a:off x="8382000" y="1536192"/>
+            <a:ext cx="3395472" cy="420624"/>
+          </a:xfrm>
+          <a:prstGeom prst="roundRect">
+            <a:avLst>
+              <a:gd name="adj" fmla="val 4000"/>
+            </a:avLst>
+          </a:prstGeom>
+          <a:solidFill>
+            <a:srgbClr val="ECF6EC"/>
+          </a:solidFill>
+          <a:ln w="12700">
+            <a:solidFill>
+              <a:srgbClr val="1A6B1A"/>
+            </a:solidFill>
+          </a:ln>
+          <a:effectLst/>
+        </p:spPr>
+        <p:style>
+          <a:lnRef idx="1">
+            <a:schemeClr val="accent1"/>
+          </a:lnRef>
+          <a:fillRef idx="3">
+            <a:schemeClr val="accent1"/>
+          </a:fillRef>
+          <a:effectRef idx="2">
+            <a:schemeClr val="accent1"/>
+          </a:effectRef>
+          <a:fontRef idx="minor">
+            <a:schemeClr val="lt1"/>
+          </a:fontRef>
+        </p:style>
+        <p:txBody>
+          <a:bodyPr rtlCol="0" anchor="ctr"/>
+          <a:lstStyle/>
+          <a:p>
+            <a:pPr algn="ctr"/>
+          </a:p>
+        </p:txBody>
+      </p:sp>
+      <p:sp>
+        <p:nvSpPr>
+          <p:cNvPr id="40" name="TextBox 39"/>
+          <p:cNvSpPr txBox="1"/>
+          <p:nvPr/>
+        </p:nvSpPr>
+        <p:spPr>
+          <a:xfrm>
+            <a:off x="8400288" y="1536192"/>
+            <a:ext cx="3358896" cy="420624"/>
           </a:xfrm>
           <a:prstGeom prst="rect">
             <a:avLst/>
           </a:prstGeom>
-        </p:spPr>
-      </p:pic>
-      <p:pic>
-        <p:nvPicPr>
-          <p:cNvPr id="35" name="Picture 34" descr="me5_ms.png"/>
-          <p:cNvPicPr>
-            <a:picLocks noChangeAspect="1"/>
-          </p:cNvPicPr>
-          <p:nvPr/>
-        </p:nvPicPr>
-        <p:blipFill>
-          <a:blip r:embed="rId9"/>
-          <a:stretch>
-            <a:fillRect/>
-          </a:stretch>
-        </p:blipFill>
-        <p:spPr>
-          <a:xfrm>
-            <a:off x="5891784" y="3977639"/>
-            <a:ext cx="457200" cy="457200"/>
-          </a:xfrm>
-          <a:prstGeom prst="rect">
-            <a:avLst/>
-          </a:prstGeom>
-        </p:spPr>
-      </p:pic>
-      <p:pic>
-        <p:nvPicPr>
-          <p:cNvPr id="36" name="Picture 35" descr="qwen.png"/>
-          <p:cNvPicPr>
-            <a:picLocks noChangeAspect="1"/>
-          </p:cNvPicPr>
-          <p:nvPr/>
-        </p:nvPicPr>
-        <p:blipFill>
-          <a:blip r:embed="rId2"/>
-          <a:stretch>
-            <a:fillRect/>
-          </a:stretch>
-        </p:blipFill>
-        <p:spPr>
-          <a:xfrm>
-            <a:off x="6806184" y="3977639"/>
-            <a:ext cx="457200" cy="457200"/>
-          </a:xfrm>
-          <a:prstGeom prst="rect">
-            <a:avLst/>
-          </a:prstGeom>
-        </p:spPr>
-      </p:pic>
-      <p:sp>
-        <p:nvSpPr>
-          <p:cNvPr id="37" name="TextBox 36"/>
+          <a:noFill/>
+        </p:spPr>
+        <p:txBody>
+          <a:bodyPr wrap="square" anchor="ctr" lIns="38100" rIns="38100" tIns="25400" bIns="25400">
+            <a:spAutoFit/>
+          </a:bodyPr>
+          <a:lstStyle/>
+          <a:p>
+            <a:pPr algn="l">
+              <a:lnSpc>
+                <a:spcPct val="110000"/>
+              </a:lnSpc>
+            </a:pPr>
+            <a:r>
+              <a:rPr sz="950" b="1" i="0">
+                <a:solidFill>
+                  <a:srgbClr val="1A6B1A"/>
+                </a:solidFill>
+                <a:latin typeface="Calibri"/>
+                <a:ea typeface="Calibri"/>
+                <a:cs typeface="Calibri"/>
+              </a:rPr>
+              <a:t>RADP-Distill — edit-distance → GT</a:t>
+            </a:r>
+          </a:p>
+        </p:txBody>
+      </p:sp>
+      <p:sp>
+        <p:nvSpPr>
+          <p:cNvPr id="41" name="TextBox 40"/>
           <p:cNvSpPr txBox="1"/>
           <p:nvPr/>
         </p:nvSpPr>
         <p:spPr>
           <a:xfrm>
-            <a:off x="4291584" y="4453128"/>
-            <a:ext cx="3578352" cy="219456"/>
+            <a:off x="8199120" y="1975104"/>
+            <a:ext cx="3761232" cy="201168"/>
           </a:xfrm>
           <a:prstGeom prst="rect">
             <a:avLst/>
@@ -4598,29 +5008,77 @@
               </a:lnSpc>
             </a:pPr>
             <a:r>
-              <a:rPr sz="850" b="0" i="1">
+              <a:rPr sz="1300" b="1" i="0">
                 <a:solidFill>
-                  <a:srgbClr val="555555"/>
+                  <a:srgbClr val="202020"/>
                 </a:solidFill>
                 <a:latin typeface="Calibri"/>
                 <a:ea typeface="Calibri"/>
                 <a:cs typeface="Calibri"/>
               </a:rPr>
-              <a:t>BGE-M3 · mE5 · Qwen3-Emb</a:t>
-            </a:r>
-          </a:p>
-        </p:txBody>
-      </p:sp>
-      <p:sp>
-        <p:nvSpPr>
-          <p:cNvPr id="38" name="TextBox 37"/>
+              <a:t>≈</a:t>
+            </a:r>
+          </a:p>
+        </p:txBody>
+      </p:sp>
+      <p:sp>
+        <p:nvSpPr>
+          <p:cNvPr id="42" name="Rounded Rectangle 41"/>
+          <p:cNvSpPr/>
+          <p:nvPr/>
+        </p:nvSpPr>
+        <p:spPr>
+          <a:xfrm>
+            <a:off x="8382000" y="2048255"/>
+            <a:ext cx="3395472" cy="384048"/>
+          </a:xfrm>
+          <a:prstGeom prst="roundRect">
+            <a:avLst>
+              <a:gd name="adj" fmla="val 4000"/>
+            </a:avLst>
+          </a:prstGeom>
+          <a:solidFill>
+            <a:srgbClr val="FCF3E6"/>
+          </a:solidFill>
+          <a:ln w="12700">
+            <a:solidFill>
+              <a:srgbClr val="9A5A00"/>
+            </a:solidFill>
+          </a:ln>
+          <a:effectLst/>
+        </p:spPr>
+        <p:style>
+          <a:lnRef idx="1">
+            <a:schemeClr val="accent1"/>
+          </a:lnRef>
+          <a:fillRef idx="3">
+            <a:schemeClr val="accent1"/>
+          </a:fillRef>
+          <a:effectRef idx="2">
+            <a:schemeClr val="accent1"/>
+          </a:effectRef>
+          <a:fontRef idx="minor">
+            <a:schemeClr val="lt1"/>
+          </a:fontRef>
+        </p:style>
+        <p:txBody>
+          <a:bodyPr rtlCol="0" anchor="ctr"/>
+          <a:lstStyle/>
+          <a:p>
+            <a:pPr algn="ctr"/>
+          </a:p>
+        </p:txBody>
+      </p:sp>
+      <p:sp>
+        <p:nvSpPr>
+          <p:cNvPr id="43" name="TextBox 42"/>
           <p:cNvSpPr txBox="1"/>
           <p:nvPr/>
         </p:nvSpPr>
         <p:spPr>
           <a:xfrm>
-            <a:off x="4309872" y="4553712"/>
-            <a:ext cx="3541776" cy="310896"/>
+            <a:off x="8400288" y="2048255"/>
+            <a:ext cx="3358896" cy="384048"/>
           </a:xfrm>
           <a:prstGeom prst="rect">
             <a:avLst/>
@@ -4628,18 +5086,18 @@
           <a:noFill/>
         </p:spPr>
         <p:txBody>
-          <a:bodyPr wrap="square" anchor="t" lIns="38100" rIns="38100" tIns="25400" bIns="25400">
+          <a:bodyPr wrap="square" anchor="ctr" lIns="38100" rIns="38100" tIns="25400" bIns="25400">
             <a:spAutoFit/>
           </a:bodyPr>
           <a:lstStyle/>
           <a:p>
-            <a:pPr algn="ctr">
+            <a:pPr algn="l">
               <a:lnSpc>
                 <a:spcPct val="110000"/>
               </a:lnSpc>
             </a:pPr>
             <a:r>
-              <a:rPr sz="1050" b="1" i="0">
+              <a:rPr sz="950" b="1" i="0">
                 <a:solidFill>
                   <a:srgbClr val="9A5A00"/>
                 </a:solidFill>
@@ -4647,21 +5105,21 @@
                 <a:ea typeface="Calibri"/>
                 <a:cs typeface="Calibri"/>
               </a:rPr>
-              <a:t>→ rank parsers &amp; chunkers by retrieval</a:t>
-            </a:r>
-          </a:p>
-        </p:txBody>
-      </p:sp>
-      <p:sp>
-        <p:nvSpPr>
-          <p:cNvPr id="39" name="Rounded Rectangle 38"/>
+              <a:t>RADP-DPO — page-local RCPS</a:t>
+            </a:r>
+          </a:p>
+        </p:txBody>
+      </p:sp>
+      <p:sp>
+        <p:nvSpPr>
+          <p:cNvPr id="44" name="Rounded Rectangle 43"/>
           <p:cNvSpPr/>
           <p:nvPr/>
         </p:nvSpPr>
         <p:spPr>
           <a:xfrm>
-            <a:off x="8199120" y="749808"/>
-            <a:ext cx="3761232" cy="1783080"/>
+            <a:off x="8199120" y="2679192"/>
+            <a:ext cx="3761232" cy="2240280"/>
           </a:xfrm>
           <a:prstGeom prst="roundRect">
             <a:avLst>
@@ -4702,13 +5160,13 @@
       </p:sp>
       <p:sp>
         <p:nvSpPr>
-          <p:cNvPr id="40" name="Rounded Rectangle 39"/>
+          <p:cNvPr id="45" name="Rounded Rectangle 44"/>
           <p:cNvSpPr/>
           <p:nvPr/>
         </p:nvSpPr>
         <p:spPr>
           <a:xfrm>
-            <a:off x="8199120" y="749808"/>
+            <a:off x="8199120" y="2679192"/>
             <a:ext cx="3761232" cy="310896"/>
           </a:xfrm>
           <a:prstGeom prst="roundRect">
@@ -4748,13 +5206,13 @@
       </p:sp>
       <p:sp>
         <p:nvSpPr>
-          <p:cNvPr id="41" name="TextBox 40"/>
+          <p:cNvPr id="46" name="TextBox 45"/>
           <p:cNvSpPr txBox="1"/>
           <p:nvPr/>
         </p:nvSpPr>
         <p:spPr>
           <a:xfrm>
-            <a:off x="8244840" y="749808"/>
+            <a:off x="8244840" y="2679192"/>
             <a:ext cx="3669792" cy="310896"/>
           </a:xfrm>
           <a:prstGeom prst="rect">
@@ -4782,21 +5240,45 @@
                 <a:ea typeface="Calibri"/>
                 <a:cs typeface="Calibri"/>
               </a:rPr>
-              <a:t>C4 · Parser-side training</a:t>
-            </a:r>
-          </a:p>
-        </p:txBody>
-      </p:sp>
-      <p:sp>
-        <p:nvSpPr>
-          <p:cNvPr id="42" name="TextBox 41"/>
+              <a:t>Result</a:t>
+            </a:r>
+          </a:p>
+        </p:txBody>
+      </p:sp>
+      <p:pic>
+        <p:nvPicPr>
+          <p:cNvPr id="47" name="Picture 46" descr="fig_c4_training.png"/>
+          <p:cNvPicPr>
+            <a:picLocks noChangeAspect="1"/>
+          </p:cNvPicPr>
+          <p:nvPr/>
+        </p:nvPicPr>
+        <p:blipFill>
+          <a:blip r:embed="rId9"/>
+          <a:stretch>
+            <a:fillRect/>
+          </a:stretch>
+        </p:blipFill>
+        <p:spPr>
+          <a:xfrm>
+            <a:off x="8729359" y="3044952"/>
+            <a:ext cx="2700753" cy="1325880"/>
+          </a:xfrm>
+          <a:prstGeom prst="rect">
+            <a:avLst/>
+          </a:prstGeom>
+        </p:spPr>
+      </p:pic>
+      <p:sp>
+        <p:nvSpPr>
+          <p:cNvPr id="48" name="TextBox 47"/>
           <p:cNvSpPr txBox="1"/>
           <p:nvPr/>
         </p:nvSpPr>
         <p:spPr>
           <a:xfrm>
-            <a:off x="8327136" y="1152144"/>
-            <a:ext cx="3505200" cy="365760"/>
+            <a:off x="8308848" y="4370832"/>
+            <a:ext cx="3541776" cy="502920"/>
           </a:xfrm>
           <a:prstGeom prst="rect">
             <a:avLst/>
@@ -4809,48 +5291,62 @@
           </a:bodyPr>
           <a:lstStyle/>
           <a:p>
-            <a:pPr algn="l">
+            <a:pPr algn="ctr">
               <a:lnSpc>
                 <a:spcPct val="110000"/>
               </a:lnSpc>
             </a:pPr>
             <a:r>
-              <a:rPr sz="950" b="0" i="0">
+              <a:rPr sz="950" b="1" i="0">
                 <a:solidFill>
-                  <a:srgbClr val="202020"/>
+                  <a:srgbClr val="1A6B1A"/>
                 </a:solidFill>
                 <a:latin typeface="Calibri"/>
                 <a:ea typeface="Calibri"/>
                 <a:cs typeface="Calibri"/>
               </a:rPr>
-              <a:t>best-of-K parses from Prod, ranked two ways:</a:t>
-            </a:r>
-          </a:p>
-        </p:txBody>
-      </p:sp>
-      <p:sp>
-        <p:nvSpPr>
-          <p:cNvPr id="43" name="Rounded Rectangle 42"/>
+              <a:t>the two signals tie → retrieval reward unnecessary</a:t>
+            </a:r>
+          </a:p>
+          <a:p>
+            <a:pPr algn="ctr">
+              <a:lnSpc>
+                <a:spcPct val="110000"/>
+              </a:lnSpc>
+            </a:pPr>
+            <a:r>
+              <a:rPr sz="880" b="0" i="1">
+                <a:solidFill>
+                  <a:srgbClr val="555555"/>
+                </a:solidFill>
+                <a:latin typeface="Calibri"/>
+                <a:ea typeface="Calibri"/>
+                <a:cs typeface="Calibri"/>
+              </a:rPr>
+              <a:t>the deployable lever is fidelity distillation</a:t>
+            </a:r>
+          </a:p>
+        </p:txBody>
+      </p:sp>
+      <p:sp>
+        <p:nvSpPr>
+          <p:cNvPr id="49" name="Chevron 48"/>
           <p:cNvSpPr/>
           <p:nvPr/>
         </p:nvSpPr>
         <p:spPr>
           <a:xfrm>
-            <a:off x="8382000" y="1536192"/>
-            <a:ext cx="3395472" cy="420624"/>
-          </a:xfrm>
-          <a:prstGeom prst="roundRect">
-            <a:avLst>
-              <a:gd name="adj" fmla="val 4000"/>
-            </a:avLst>
+            <a:off x="3971544" y="2514600"/>
+            <a:ext cx="219456" cy="548640"/>
+          </a:xfrm>
+          <a:prstGeom prst="chevron">
+            <a:avLst/>
           </a:prstGeom>
           <a:solidFill>
-            <a:srgbClr val="ECF6EC"/>
+            <a:srgbClr val="9A5A00"/>
           </a:solidFill>
-          <a:ln w="12700">
-            <a:solidFill>
-              <a:srgbClr val="1A6B1A"/>
-            </a:solidFill>
+          <a:ln>
+            <a:noFill/>
           </a:ln>
           <a:effectLst/>
         </p:spPr>
@@ -4878,109 +5374,23 @@
       </p:sp>
       <p:sp>
         <p:nvSpPr>
-          <p:cNvPr id="44" name="TextBox 43"/>
-          <p:cNvSpPr txBox="1"/>
+          <p:cNvPr id="50" name="Chevron 49"/>
+          <p:cNvSpPr/>
           <p:nvPr/>
         </p:nvSpPr>
         <p:spPr>
           <a:xfrm>
-            <a:off x="8400288" y="1536192"/>
-            <a:ext cx="3358896" cy="420624"/>
-          </a:xfrm>
-          <a:prstGeom prst="rect">
+            <a:off x="7970520" y="2514600"/>
+            <a:ext cx="219456" cy="548640"/>
+          </a:xfrm>
+          <a:prstGeom prst="chevron">
             <a:avLst/>
           </a:prstGeom>
-          <a:noFill/>
-        </p:spPr>
-        <p:txBody>
-          <a:bodyPr wrap="square" anchor="ctr" lIns="38100" rIns="38100" tIns="25400" bIns="25400">
-            <a:spAutoFit/>
-          </a:bodyPr>
-          <a:lstStyle/>
-          <a:p>
-            <a:pPr algn="l">
-              <a:lnSpc>
-                <a:spcPct val="110000"/>
-              </a:lnSpc>
-            </a:pPr>
-            <a:r>
-              <a:rPr sz="950" b="1" i="0">
-                <a:solidFill>
-                  <a:srgbClr val="1A6B1A"/>
-                </a:solidFill>
-                <a:latin typeface="Calibri"/>
-                <a:ea typeface="Calibri"/>
-                <a:cs typeface="Calibri"/>
-              </a:rPr>
-              <a:t>RADP-Distill — edit-distance → GT</a:t>
-            </a:r>
-          </a:p>
-        </p:txBody>
-      </p:sp>
-      <p:sp>
-        <p:nvSpPr>
-          <p:cNvPr id="45" name="TextBox 44"/>
-          <p:cNvSpPr txBox="1"/>
-          <p:nvPr/>
-        </p:nvSpPr>
-        <p:spPr>
-          <a:xfrm>
-            <a:off x="8199120" y="1975104"/>
-            <a:ext cx="3761232" cy="201168"/>
-          </a:xfrm>
-          <a:prstGeom prst="rect">
-            <a:avLst/>
-          </a:prstGeom>
-          <a:noFill/>
-        </p:spPr>
-        <p:txBody>
-          <a:bodyPr wrap="square" anchor="t" lIns="38100" rIns="38100" tIns="25400" bIns="25400">
-            <a:spAutoFit/>
-          </a:bodyPr>
-          <a:lstStyle/>
-          <a:p>
-            <a:pPr algn="ctr">
-              <a:lnSpc>
-                <a:spcPct val="110000"/>
-              </a:lnSpc>
-            </a:pPr>
-            <a:r>
-              <a:rPr sz="1300" b="1" i="0">
-                <a:solidFill>
-                  <a:srgbClr val="202020"/>
-                </a:solidFill>
-                <a:latin typeface="Calibri"/>
-                <a:ea typeface="Calibri"/>
-                <a:cs typeface="Calibri"/>
-              </a:rPr>
-              <a:t>≈</a:t>
-            </a:r>
-          </a:p>
-        </p:txBody>
-      </p:sp>
-      <p:sp>
-        <p:nvSpPr>
-          <p:cNvPr id="46" name="Rounded Rectangle 45"/>
-          <p:cNvSpPr/>
-          <p:nvPr/>
-        </p:nvSpPr>
-        <p:spPr>
-          <a:xfrm>
-            <a:off x="8382000" y="2048255"/>
-            <a:ext cx="3395472" cy="384048"/>
-          </a:xfrm>
-          <a:prstGeom prst="roundRect">
-            <a:avLst>
-              <a:gd name="adj" fmla="val 4000"/>
-            </a:avLst>
-          </a:prstGeom>
           <a:solidFill>
-            <a:srgbClr val="FCF3E6"/>
+            <a:srgbClr val="1A6B1A"/>
           </a:solidFill>
-          <a:ln w="12700">
-            <a:solidFill>
-              <a:srgbClr val="9A5A00"/>
-            </a:solidFill>
+          <a:ln>
+            <a:noFill/>
           </a:ln>
           <a:effectLst/>
         </p:spPr>
@@ -5003,440 +5413,6 @@
           <a:lstStyle/>
           <a:p>
             <a:pPr algn="ctr"/>
-          </a:p>
-        </p:txBody>
-      </p:sp>
-      <p:sp>
-        <p:nvSpPr>
-          <p:cNvPr id="47" name="TextBox 46"/>
-          <p:cNvSpPr txBox="1"/>
-          <p:nvPr/>
-        </p:nvSpPr>
-        <p:spPr>
-          <a:xfrm>
-            <a:off x="8400288" y="2048255"/>
-            <a:ext cx="3358896" cy="384048"/>
-          </a:xfrm>
-          <a:prstGeom prst="rect">
-            <a:avLst/>
-          </a:prstGeom>
-          <a:noFill/>
-        </p:spPr>
-        <p:txBody>
-          <a:bodyPr wrap="square" anchor="ctr" lIns="38100" rIns="38100" tIns="25400" bIns="25400">
-            <a:spAutoFit/>
-          </a:bodyPr>
-          <a:lstStyle/>
-          <a:p>
-            <a:pPr algn="l">
-              <a:lnSpc>
-                <a:spcPct val="110000"/>
-              </a:lnSpc>
-            </a:pPr>
-            <a:r>
-              <a:rPr sz="950" b="1" i="0">
-                <a:solidFill>
-                  <a:srgbClr val="9A5A00"/>
-                </a:solidFill>
-                <a:latin typeface="Calibri"/>
-                <a:ea typeface="Calibri"/>
-                <a:cs typeface="Calibri"/>
-              </a:rPr>
-              <a:t>RADP-DPO — page-local RCPS</a:t>
-            </a:r>
-          </a:p>
-        </p:txBody>
-      </p:sp>
-      <p:sp>
-        <p:nvSpPr>
-          <p:cNvPr id="48" name="Rounded Rectangle 47"/>
-          <p:cNvSpPr/>
-          <p:nvPr/>
-        </p:nvSpPr>
-        <p:spPr>
-          <a:xfrm>
-            <a:off x="8199120" y="2679192"/>
-            <a:ext cx="3761232" cy="2240280"/>
-          </a:xfrm>
-          <a:prstGeom prst="roundRect">
-            <a:avLst>
-              <a:gd name="adj" fmla="val 4000"/>
-            </a:avLst>
-          </a:prstGeom>
-          <a:solidFill>
-            <a:srgbClr val="FFFFFF"/>
-          </a:solidFill>
-          <a:ln w="15875">
-            <a:solidFill>
-              <a:srgbClr val="1A6B1A"/>
-            </a:solidFill>
-          </a:ln>
-          <a:effectLst/>
-        </p:spPr>
-        <p:style>
-          <a:lnRef idx="1">
-            <a:schemeClr val="accent1"/>
-          </a:lnRef>
-          <a:fillRef idx="3">
-            <a:schemeClr val="accent1"/>
-          </a:fillRef>
-          <a:effectRef idx="2">
-            <a:schemeClr val="accent1"/>
-          </a:effectRef>
-          <a:fontRef idx="minor">
-            <a:schemeClr val="lt1"/>
-          </a:fontRef>
-        </p:style>
-        <p:txBody>
-          <a:bodyPr rtlCol="0" anchor="ctr"/>
-          <a:lstStyle/>
-          <a:p>
-            <a:pPr algn="ctr"/>
-          </a:p>
-        </p:txBody>
-      </p:sp>
-      <p:sp>
-        <p:nvSpPr>
-          <p:cNvPr id="49" name="Rounded Rectangle 48"/>
-          <p:cNvSpPr/>
-          <p:nvPr/>
-        </p:nvSpPr>
-        <p:spPr>
-          <a:xfrm>
-            <a:off x="8199120" y="2679192"/>
-            <a:ext cx="3761232" cy="310896"/>
-          </a:xfrm>
-          <a:prstGeom prst="roundRect">
-            <a:avLst>
-              <a:gd name="adj" fmla="val 10000"/>
-            </a:avLst>
-          </a:prstGeom>
-          <a:solidFill>
-            <a:srgbClr val="ECF6EC"/>
-          </a:solidFill>
-          <a:ln>
-            <a:noFill/>
-          </a:ln>
-          <a:effectLst/>
-        </p:spPr>
-        <p:style>
-          <a:lnRef idx="1">
-            <a:schemeClr val="accent1"/>
-          </a:lnRef>
-          <a:fillRef idx="3">
-            <a:schemeClr val="accent1"/>
-          </a:fillRef>
-          <a:effectRef idx="2">
-            <a:schemeClr val="accent1"/>
-          </a:effectRef>
-          <a:fontRef idx="minor">
-            <a:schemeClr val="lt1"/>
-          </a:fontRef>
-        </p:style>
-        <p:txBody>
-          <a:bodyPr rtlCol="0" anchor="ctr"/>
-          <a:lstStyle/>
-          <a:p>
-            <a:pPr algn="ctr"/>
-          </a:p>
-        </p:txBody>
-      </p:sp>
-      <p:sp>
-        <p:nvSpPr>
-          <p:cNvPr id="50" name="TextBox 49"/>
-          <p:cNvSpPr txBox="1"/>
-          <p:nvPr/>
-        </p:nvSpPr>
-        <p:spPr>
-          <a:xfrm>
-            <a:off x="8244840" y="2679192"/>
-            <a:ext cx="3669792" cy="310896"/>
-          </a:xfrm>
-          <a:prstGeom prst="rect">
-            <a:avLst/>
-          </a:prstGeom>
-          <a:noFill/>
-        </p:spPr>
-        <p:txBody>
-          <a:bodyPr wrap="square" anchor="ctr" lIns="38100" rIns="38100" tIns="25400" bIns="25400">
-            <a:spAutoFit/>
-          </a:bodyPr>
-          <a:lstStyle/>
-          <a:p>
-            <a:pPr algn="l">
-              <a:lnSpc>
-                <a:spcPct val="110000"/>
-              </a:lnSpc>
-            </a:pPr>
-            <a:r>
-              <a:rPr sz="1050" b="1" i="0">
-                <a:solidFill>
-                  <a:srgbClr val="1A6B1A"/>
-                </a:solidFill>
-                <a:latin typeface="Calibri"/>
-                <a:ea typeface="Calibri"/>
-                <a:cs typeface="Calibri"/>
-              </a:rPr>
-              <a:t>Result</a:t>
-            </a:r>
-          </a:p>
-        </p:txBody>
-      </p:sp>
-      <p:pic>
-        <p:nvPicPr>
-          <p:cNvPr id="51" name="Picture 50" descr="fig_c4_training.png"/>
-          <p:cNvPicPr>
-            <a:picLocks noChangeAspect="1"/>
-          </p:cNvPicPr>
-          <p:nvPr/>
-        </p:nvPicPr>
-        <p:blipFill>
-          <a:blip r:embed="rId10"/>
-          <a:stretch>
-            <a:fillRect/>
-          </a:stretch>
-        </p:blipFill>
-        <p:spPr>
-          <a:xfrm>
-            <a:off x="8729359" y="3044952"/>
-            <a:ext cx="2700753" cy="1325880"/>
-          </a:xfrm>
-          <a:prstGeom prst="rect">
-            <a:avLst/>
-          </a:prstGeom>
-        </p:spPr>
-      </p:pic>
-      <p:sp>
-        <p:nvSpPr>
-          <p:cNvPr id="52" name="TextBox 51"/>
-          <p:cNvSpPr txBox="1"/>
-          <p:nvPr/>
-        </p:nvSpPr>
-        <p:spPr>
-          <a:xfrm>
-            <a:off x="8308848" y="4370832"/>
-            <a:ext cx="3541776" cy="502920"/>
-          </a:xfrm>
-          <a:prstGeom prst="rect">
-            <a:avLst/>
-          </a:prstGeom>
-          <a:noFill/>
-        </p:spPr>
-        <p:txBody>
-          <a:bodyPr wrap="square" anchor="t" lIns="38100" rIns="38100" tIns="25400" bIns="25400">
-            <a:spAutoFit/>
-          </a:bodyPr>
-          <a:lstStyle/>
-          <a:p>
-            <a:pPr algn="ctr">
-              <a:lnSpc>
-                <a:spcPct val="110000"/>
-              </a:lnSpc>
-            </a:pPr>
-            <a:r>
-              <a:rPr sz="950" b="1" i="0">
-                <a:solidFill>
-                  <a:srgbClr val="1A6B1A"/>
-                </a:solidFill>
-                <a:latin typeface="Calibri"/>
-                <a:ea typeface="Calibri"/>
-                <a:cs typeface="Calibri"/>
-              </a:rPr>
-              <a:t>the two signals tie → retrieval reward unnecessary</a:t>
-            </a:r>
-          </a:p>
-          <a:p>
-            <a:pPr algn="ctr">
-              <a:lnSpc>
-                <a:spcPct val="110000"/>
-              </a:lnSpc>
-            </a:pPr>
-            <a:r>
-              <a:rPr sz="880" b="0" i="1">
-                <a:solidFill>
-                  <a:srgbClr val="555555"/>
-                </a:solidFill>
-                <a:latin typeface="Calibri"/>
-                <a:ea typeface="Calibri"/>
-                <a:cs typeface="Calibri"/>
-              </a:rPr>
-              <a:t>the deployable lever is fidelity distillation</a:t>
-            </a:r>
-          </a:p>
-        </p:txBody>
-      </p:sp>
-      <p:sp>
-        <p:nvSpPr>
-          <p:cNvPr id="53" name="Chevron 52"/>
-          <p:cNvSpPr/>
-          <p:nvPr/>
-        </p:nvSpPr>
-        <p:spPr>
-          <a:xfrm>
-            <a:off x="3971544" y="2743200"/>
-            <a:ext cx="219456" cy="566928"/>
-          </a:xfrm>
-          <a:prstGeom prst="chevron">
-            <a:avLst/>
-          </a:prstGeom>
-          <a:solidFill>
-            <a:srgbClr val="9A5A00"/>
-          </a:solidFill>
-          <a:ln>
-            <a:noFill/>
-          </a:ln>
-          <a:effectLst/>
-        </p:spPr>
-        <p:style>
-          <a:lnRef idx="1">
-            <a:schemeClr val="accent1"/>
-          </a:lnRef>
-          <a:fillRef idx="3">
-            <a:schemeClr val="accent1"/>
-          </a:fillRef>
-          <a:effectRef idx="2">
-            <a:schemeClr val="accent1"/>
-          </a:effectRef>
-          <a:fontRef idx="minor">
-            <a:schemeClr val="lt1"/>
-          </a:fontRef>
-        </p:style>
-        <p:txBody>
-          <a:bodyPr rtlCol="0" anchor="ctr"/>
-          <a:lstStyle/>
-          <a:p>
-            <a:pPr algn="ctr"/>
-          </a:p>
-        </p:txBody>
-      </p:sp>
-      <p:sp>
-        <p:nvSpPr>
-          <p:cNvPr id="54" name="Chevron 53"/>
-          <p:cNvSpPr/>
-          <p:nvPr/>
-        </p:nvSpPr>
-        <p:spPr>
-          <a:xfrm>
-            <a:off x="7970520" y="2743200"/>
-            <a:ext cx="219456" cy="566928"/>
-          </a:xfrm>
-          <a:prstGeom prst="chevron">
-            <a:avLst/>
-          </a:prstGeom>
-          <a:solidFill>
-            <a:srgbClr val="1A6B1A"/>
-          </a:solidFill>
-          <a:ln>
-            <a:noFill/>
-          </a:ln>
-          <a:effectLst/>
-        </p:spPr>
-        <p:style>
-          <a:lnRef idx="1">
-            <a:schemeClr val="accent1"/>
-          </a:lnRef>
-          <a:fillRef idx="3">
-            <a:schemeClr val="accent1"/>
-          </a:fillRef>
-          <a:effectRef idx="2">
-            <a:schemeClr val="accent1"/>
-          </a:effectRef>
-          <a:fontRef idx="minor">
-            <a:schemeClr val="lt1"/>
-          </a:fontRef>
-        </p:style>
-        <p:txBody>
-          <a:bodyPr rtlCol="0" anchor="ctr"/>
-          <a:lstStyle/>
-          <a:p>
-            <a:pPr algn="ctr"/>
-          </a:p>
-        </p:txBody>
-      </p:sp>
-      <p:cxnSp>
-        <p:nvCxnSpPr>
-          <p:cNvPr id="55" name="Connector 54"/>
-          <p:cNvCxnSpPr/>
-          <p:nvPr/>
-        </p:nvCxnSpPr>
-        <p:spPr>
-          <a:xfrm>
-            <a:off x="201168" y="5285232"/>
-            <a:ext cx="11759184" cy="0"/>
-          </a:xfrm>
-          <a:prstGeom prst="line">
-            <a:avLst/>
-          </a:prstGeom>
-          <a:ln w="12700">
-            <a:solidFill>
-              <a:srgbClr val="CCCCCC"/>
-            </a:solidFill>
-          </a:ln>
-        </p:spPr>
-        <p:style>
-          <a:lnRef idx="2">
-            <a:schemeClr val="accent1"/>
-          </a:lnRef>
-          <a:fillRef idx="0">
-            <a:schemeClr val="accent1"/>
-          </a:fillRef>
-          <a:effectRef idx="1">
-            <a:schemeClr val="accent1"/>
-          </a:effectRef>
-          <a:fontRef idx="minor">
-            <a:schemeClr val="tx1"/>
-          </a:fontRef>
-        </p:style>
-      </p:cxnSp>
-      <p:sp>
-        <p:nvSpPr>
-          <p:cNvPr id="56" name="TextBox 55"/>
-          <p:cNvSpPr txBox="1"/>
-          <p:nvPr/>
-        </p:nvSpPr>
-        <p:spPr>
-          <a:xfrm>
-            <a:off x="201168" y="5340096"/>
-            <a:ext cx="11759184" cy="365760"/>
-          </a:xfrm>
-          <a:prstGeom prst="rect">
-            <a:avLst/>
-          </a:prstGeom>
-          <a:noFill/>
-        </p:spPr>
-        <p:txBody>
-          <a:bodyPr wrap="square" anchor="ctr" lIns="38100" rIns="38100" tIns="25400" bIns="25400">
-            <a:spAutoFit/>
-          </a:bodyPr>
-          <a:lstStyle/>
-          <a:p>
-            <a:pPr algn="ctr">
-              <a:lnSpc>
-                <a:spcPct val="110000"/>
-              </a:lnSpc>
-            </a:pPr>
-            <a:r>
-              <a:rPr sz="1300" b="1" i="0">
-                <a:solidFill>
-                  <a:srgbClr val="202020"/>
-                </a:solidFill>
-                <a:latin typeface="Calibri"/>
-                <a:ea typeface="Calibri"/>
-                <a:cs typeface="Calibri"/>
-              </a:rPr>
-              <a:t>The parser — not the chunker — is the under-examined lever:  choose it by retrieval, not by appearance   </a:t>
-            </a:r>
-            <a:r>
-              <a:rPr sz="1300" b="1" i="0">
-                <a:solidFill>
-                  <a:srgbClr val="1F5FA8"/>
-                </a:solidFill>
-                <a:latin typeface="Calibri"/>
-                <a:ea typeface="Calibri"/>
-                <a:cs typeface="Calibri"/>
-              </a:rPr>
-              <a:t>(Hit@1 0.20 → 0.55, 2.8×)</a:t>
-            </a:r>
           </a:p>
         </p:txBody>
       </p:sp>

</xml_diff>

<commit_message>
fig: overview C2/C4 -> native clean visuals; drop embedded body charts
Embedding the standalone body charts (fig_coverage, fig_c4_training) dragged
in their own labels/jargon -- 'untuned parser (v1)', n=2264, CI whiskers,
chunker x-axis -- which read as unexplained noise in the overview. Replace
with native PowerPoint visuals consistent with C1's table:
  C2: a single covered/split/absent stacked bar (77.5/—/20.2) + 'absent =
      answer never reached parser output (parser fault); constant across 8
      chunkers -> chunking can't recover it'.
  C4: 'Hit@5 gain over the untuned parser' + two clean bars (RADP-Distill
      +1.22, RADP-DPO +0.85) + 'overlapping CIs -> reward unnecessary'.
All four columns now use consistent jargon-free native shapes.
</commit_message>
<xml_diff>
--- a/paper/figures/fig_overview.pptx
+++ b/paper/figures/fig_overview.pptx
@@ -4302,9 +4302,598 @@
           </a:p>
         </p:txBody>
       </p:sp>
+      <p:sp>
+        <p:nvSpPr>
+          <p:cNvPr id="24" name="TextBox 23"/>
+          <p:cNvSpPr txBox="1"/>
+          <p:nvPr/>
+        </p:nvSpPr>
+        <p:spPr>
+          <a:xfrm>
+            <a:off x="4328160" y="1115568"/>
+            <a:ext cx="3505200" cy="274320"/>
+          </a:xfrm>
+          <a:prstGeom prst="rect">
+            <a:avLst/>
+          </a:prstGeom>
+          <a:noFill/>
+        </p:spPr>
+        <p:txBody>
+          <a:bodyPr wrap="square" anchor="t" lIns="38100" rIns="38100" tIns="25400" bIns="25400">
+            <a:spAutoFit/>
+          </a:bodyPr>
+          <a:lstStyle/>
+          <a:p>
+            <a:pPr algn="l">
+              <a:lnSpc>
+                <a:spcPct val="110000"/>
+              </a:lnSpc>
+            </a:pPr>
+            <a:r>
+              <a:rPr sz="950" b="0" i="0">
+                <a:solidFill>
+                  <a:srgbClr val="202020"/>
+                </a:solidFill>
+                <a:latin typeface="Calibri"/>
+                <a:ea typeface="Calibri"/>
+                <a:cs typeface="Calibri"/>
+              </a:rPr>
+              <a:t>where does each gold answer land?</a:t>
+            </a:r>
+          </a:p>
+        </p:txBody>
+      </p:sp>
+      <p:sp>
+        <p:nvSpPr>
+          <p:cNvPr id="25" name="Rectangle 24"/>
+          <p:cNvSpPr/>
+          <p:nvPr/>
+        </p:nvSpPr>
+        <p:spPr>
+          <a:xfrm>
+            <a:off x="4428744" y="1517904"/>
+            <a:ext cx="2560624" cy="548640"/>
+          </a:xfrm>
+          <a:prstGeom prst="rect">
+            <a:avLst/>
+          </a:prstGeom>
+          <a:solidFill>
+            <a:srgbClr val="4A9A4A"/>
+          </a:solidFill>
+          <a:ln w="9525">
+            <a:solidFill>
+              <a:srgbClr val="FFFFFF"/>
+            </a:solidFill>
+          </a:ln>
+          <a:effectLst/>
+        </p:spPr>
+        <p:style>
+          <a:lnRef idx="1">
+            <a:schemeClr val="accent1"/>
+          </a:lnRef>
+          <a:fillRef idx="3">
+            <a:schemeClr val="accent1"/>
+          </a:fillRef>
+          <a:effectRef idx="2">
+            <a:schemeClr val="accent1"/>
+          </a:effectRef>
+          <a:fontRef idx="minor">
+            <a:schemeClr val="lt1"/>
+          </a:fontRef>
+        </p:style>
+        <p:txBody>
+          <a:bodyPr rtlCol="0" anchor="ctr"/>
+          <a:lstStyle/>
+          <a:p>
+            <a:pPr algn="ctr"/>
+          </a:p>
+        </p:txBody>
+      </p:sp>
+      <p:sp>
+        <p:nvSpPr>
+          <p:cNvPr id="26" name="Rectangle 25"/>
+          <p:cNvSpPr/>
+          <p:nvPr/>
+        </p:nvSpPr>
+        <p:spPr>
+          <a:xfrm>
+            <a:off x="6989368" y="1517904"/>
+            <a:ext cx="75992" cy="548640"/>
+          </a:xfrm>
+          <a:prstGeom prst="rect">
+            <a:avLst/>
+          </a:prstGeom>
+          <a:solidFill>
+            <a:srgbClr val="D98A2B"/>
+          </a:solidFill>
+          <a:ln w="9525">
+            <a:solidFill>
+              <a:srgbClr val="FFFFFF"/>
+            </a:solidFill>
+          </a:ln>
+          <a:effectLst/>
+        </p:spPr>
+        <p:style>
+          <a:lnRef idx="1">
+            <a:schemeClr val="accent1"/>
+          </a:lnRef>
+          <a:fillRef idx="3">
+            <a:schemeClr val="accent1"/>
+          </a:fillRef>
+          <a:effectRef idx="2">
+            <a:schemeClr val="accent1"/>
+          </a:effectRef>
+          <a:fontRef idx="minor">
+            <a:schemeClr val="lt1"/>
+          </a:fontRef>
+        </p:style>
+        <p:txBody>
+          <a:bodyPr rtlCol="0" anchor="ctr"/>
+          <a:lstStyle/>
+          <a:p>
+            <a:pPr algn="ctr"/>
+          </a:p>
+        </p:txBody>
+      </p:sp>
+      <p:sp>
+        <p:nvSpPr>
+          <p:cNvPr id="27" name="Rectangle 26"/>
+          <p:cNvSpPr/>
+          <p:nvPr/>
+        </p:nvSpPr>
+        <p:spPr>
+          <a:xfrm>
+            <a:off x="7065361" y="1517904"/>
+            <a:ext cx="667414" cy="548640"/>
+          </a:xfrm>
+          <a:prstGeom prst="rect">
+            <a:avLst/>
+          </a:prstGeom>
+          <a:solidFill>
+            <a:srgbClr val="BE3A3A"/>
+          </a:solidFill>
+          <a:ln w="9525">
+            <a:solidFill>
+              <a:srgbClr val="FFFFFF"/>
+            </a:solidFill>
+          </a:ln>
+          <a:effectLst/>
+        </p:spPr>
+        <p:style>
+          <a:lnRef idx="1">
+            <a:schemeClr val="accent1"/>
+          </a:lnRef>
+          <a:fillRef idx="3">
+            <a:schemeClr val="accent1"/>
+          </a:fillRef>
+          <a:effectRef idx="2">
+            <a:schemeClr val="accent1"/>
+          </a:effectRef>
+          <a:fontRef idx="minor">
+            <a:schemeClr val="lt1"/>
+          </a:fontRef>
+        </p:style>
+        <p:txBody>
+          <a:bodyPr rtlCol="0" anchor="ctr"/>
+          <a:lstStyle/>
+          <a:p>
+            <a:pPr algn="ctr"/>
+          </a:p>
+        </p:txBody>
+      </p:sp>
+      <p:sp>
+        <p:nvSpPr>
+          <p:cNvPr id="28" name="TextBox 27"/>
+          <p:cNvSpPr txBox="1"/>
+          <p:nvPr/>
+        </p:nvSpPr>
+        <p:spPr>
+          <a:xfrm>
+            <a:off x="4428744" y="1517904"/>
+            <a:ext cx="2560624" cy="548640"/>
+          </a:xfrm>
+          <a:prstGeom prst="rect">
+            <a:avLst/>
+          </a:prstGeom>
+          <a:noFill/>
+        </p:spPr>
+        <p:txBody>
+          <a:bodyPr wrap="square" anchor="ctr" lIns="38100" rIns="38100" tIns="25400" bIns="25400">
+            <a:spAutoFit/>
+          </a:bodyPr>
+          <a:lstStyle/>
+          <a:p>
+            <a:pPr algn="ctr">
+              <a:lnSpc>
+                <a:spcPct val="110000"/>
+              </a:lnSpc>
+            </a:pPr>
+            <a:r>
+              <a:rPr sz="950" b="1" i="0">
+                <a:solidFill>
+                  <a:srgbClr val="FFFFFF"/>
+                </a:solidFill>
+                <a:latin typeface="Calibri"/>
+                <a:ea typeface="Calibri"/>
+                <a:cs typeface="Calibri"/>
+              </a:rPr>
+              <a:t>77.5%</a:t>
+            </a:r>
+          </a:p>
+        </p:txBody>
+      </p:sp>
+      <p:sp>
+        <p:nvSpPr>
+          <p:cNvPr id="29" name="TextBox 28"/>
+          <p:cNvSpPr txBox="1"/>
+          <p:nvPr/>
+        </p:nvSpPr>
+        <p:spPr>
+          <a:xfrm>
+            <a:off x="7065361" y="1517904"/>
+            <a:ext cx="667414" cy="548640"/>
+          </a:xfrm>
+          <a:prstGeom prst="rect">
+            <a:avLst/>
+          </a:prstGeom>
+          <a:noFill/>
+        </p:spPr>
+        <p:txBody>
+          <a:bodyPr wrap="square" anchor="ctr" lIns="38100" rIns="38100" tIns="25400" bIns="25400">
+            <a:spAutoFit/>
+          </a:bodyPr>
+          <a:lstStyle/>
+          <a:p>
+            <a:pPr algn="ctr">
+              <a:lnSpc>
+                <a:spcPct val="110000"/>
+              </a:lnSpc>
+            </a:pPr>
+            <a:r>
+              <a:rPr sz="950" b="1" i="0">
+                <a:solidFill>
+                  <a:srgbClr val="FFFFFF"/>
+                </a:solidFill>
+                <a:latin typeface="Calibri"/>
+                <a:ea typeface="Calibri"/>
+                <a:cs typeface="Calibri"/>
+              </a:rPr>
+              <a:t>20.2%</a:t>
+            </a:r>
+          </a:p>
+        </p:txBody>
+      </p:sp>
+      <p:sp>
+        <p:nvSpPr>
+          <p:cNvPr id="30" name="TextBox 29"/>
+          <p:cNvSpPr txBox="1"/>
+          <p:nvPr/>
+        </p:nvSpPr>
+        <p:spPr>
+          <a:xfrm>
+            <a:off x="4428744" y="2103120"/>
+            <a:ext cx="2560624" cy="219456"/>
+          </a:xfrm>
+          <a:prstGeom prst="rect">
+            <a:avLst/>
+          </a:prstGeom>
+          <a:noFill/>
+        </p:spPr>
+        <p:txBody>
+          <a:bodyPr wrap="square" anchor="t" lIns="38100" rIns="38100" tIns="25400" bIns="25400">
+            <a:spAutoFit/>
+          </a:bodyPr>
+          <a:lstStyle/>
+          <a:p>
+            <a:pPr algn="ctr">
+              <a:lnSpc>
+                <a:spcPct val="110000"/>
+              </a:lnSpc>
+            </a:pPr>
+            <a:r>
+              <a:rPr sz="850" b="1" i="0">
+                <a:solidFill>
+                  <a:srgbClr val="4A9A4A"/>
+                </a:solidFill>
+                <a:latin typeface="Calibri"/>
+                <a:ea typeface="Calibri"/>
+                <a:cs typeface="Calibri"/>
+              </a:rPr>
+              <a:t>covered</a:t>
+            </a:r>
+          </a:p>
+        </p:txBody>
+      </p:sp>
+      <p:sp>
+        <p:nvSpPr>
+          <p:cNvPr id="31" name="TextBox 30"/>
+          <p:cNvSpPr txBox="1"/>
+          <p:nvPr/>
+        </p:nvSpPr>
+        <p:spPr>
+          <a:xfrm>
+            <a:off x="6741566" y="2103120"/>
+            <a:ext cx="991209" cy="219456"/>
+          </a:xfrm>
+          <a:prstGeom prst="rect">
+            <a:avLst/>
+          </a:prstGeom>
+          <a:noFill/>
+        </p:spPr>
+        <p:txBody>
+          <a:bodyPr wrap="square" anchor="t" lIns="38100" rIns="38100" tIns="25400" bIns="25400">
+            <a:spAutoFit/>
+          </a:bodyPr>
+          <a:lstStyle/>
+          <a:p>
+            <a:pPr algn="ctr">
+              <a:lnSpc>
+                <a:spcPct val="110000"/>
+              </a:lnSpc>
+            </a:pPr>
+            <a:r>
+              <a:rPr sz="850" b="1" i="0">
+                <a:solidFill>
+                  <a:srgbClr val="BE3A3A"/>
+                </a:solidFill>
+                <a:latin typeface="Calibri"/>
+                <a:ea typeface="Calibri"/>
+                <a:cs typeface="Calibri"/>
+              </a:rPr>
+              <a:t>absent</a:t>
+            </a:r>
+          </a:p>
+        </p:txBody>
+      </p:sp>
+      <p:sp>
+        <p:nvSpPr>
+          <p:cNvPr id="32" name="TextBox 31"/>
+          <p:cNvSpPr txBox="1"/>
+          <p:nvPr/>
+        </p:nvSpPr>
+        <p:spPr>
+          <a:xfrm>
+            <a:off x="4328160" y="2377439"/>
+            <a:ext cx="3505200" cy="603504"/>
+          </a:xfrm>
+          <a:prstGeom prst="rect">
+            <a:avLst/>
+          </a:prstGeom>
+          <a:noFill/>
+        </p:spPr>
+        <p:txBody>
+          <a:bodyPr wrap="square" anchor="t" lIns="38100" rIns="38100" tIns="25400" bIns="25400">
+            <a:spAutoFit/>
+          </a:bodyPr>
+          <a:lstStyle/>
+          <a:p>
+            <a:pPr algn="ctr">
+              <a:lnSpc>
+                <a:spcPct val="130000"/>
+              </a:lnSpc>
+            </a:pPr>
+            <a:r>
+              <a:rPr sz="900" b="0" i="0">
+                <a:solidFill>
+                  <a:srgbClr val="202020"/>
+                </a:solidFill>
+                <a:latin typeface="Calibri"/>
+                <a:ea typeface="Calibri"/>
+                <a:cs typeface="Calibri"/>
+              </a:rPr>
+              <a:t>absent = answer never made it into the parser output </a:t>
+            </a:r>
+            <a:r>
+              <a:rPr sz="900" b="1" i="0">
+                <a:solidFill>
+                  <a:srgbClr val="8F1B1B"/>
+                </a:solidFill>
+                <a:latin typeface="Calibri"/>
+                <a:ea typeface="Calibri"/>
+                <a:cs typeface="Calibri"/>
+              </a:rPr>
+              <a:t>(parser fault)</a:t>
+            </a:r>
+          </a:p>
+          <a:p>
+            <a:pPr algn="ctr">
+              <a:lnSpc>
+                <a:spcPct val="130000"/>
+              </a:lnSpc>
+            </a:pPr>
+            <a:r>
+              <a:rPr sz="880" b="0" i="1">
+                <a:solidFill>
+                  <a:srgbClr val="555555"/>
+                </a:solidFill>
+                <a:latin typeface="Calibri"/>
+                <a:ea typeface="Calibri"/>
+                <a:cs typeface="Calibri"/>
+              </a:rPr>
+              <a:t>constant across all 8 chunkers → chunking can't recover it</a:t>
+            </a:r>
+          </a:p>
+        </p:txBody>
+      </p:sp>
+      <p:sp>
+        <p:nvSpPr>
+          <p:cNvPr id="33" name="Rounded Rectangle 32"/>
+          <p:cNvSpPr/>
+          <p:nvPr/>
+        </p:nvSpPr>
+        <p:spPr>
+          <a:xfrm>
+            <a:off x="4200144" y="3227832"/>
+            <a:ext cx="3761232" cy="1691640"/>
+          </a:xfrm>
+          <a:prstGeom prst="roundRect">
+            <a:avLst>
+              <a:gd name="adj" fmla="val 4000"/>
+            </a:avLst>
+          </a:prstGeom>
+          <a:solidFill>
+            <a:srgbClr val="FFFFFF"/>
+          </a:solidFill>
+          <a:ln w="15875">
+            <a:solidFill>
+              <a:srgbClr val="9A5A00"/>
+            </a:solidFill>
+          </a:ln>
+          <a:effectLst/>
+        </p:spPr>
+        <p:style>
+          <a:lnRef idx="1">
+            <a:schemeClr val="accent1"/>
+          </a:lnRef>
+          <a:fillRef idx="3">
+            <a:schemeClr val="accent1"/>
+          </a:fillRef>
+          <a:effectRef idx="2">
+            <a:schemeClr val="accent1"/>
+          </a:effectRef>
+          <a:fontRef idx="minor">
+            <a:schemeClr val="lt1"/>
+          </a:fontRef>
+        </p:style>
+        <p:txBody>
+          <a:bodyPr rtlCol="0" anchor="ctr"/>
+          <a:lstStyle/>
+          <a:p>
+            <a:pPr algn="ctr"/>
+          </a:p>
+        </p:txBody>
+      </p:sp>
+      <p:sp>
+        <p:nvSpPr>
+          <p:cNvPr id="34" name="Rounded Rectangle 33"/>
+          <p:cNvSpPr/>
+          <p:nvPr/>
+        </p:nvSpPr>
+        <p:spPr>
+          <a:xfrm>
+            <a:off x="4200144" y="3227832"/>
+            <a:ext cx="3761232" cy="310896"/>
+          </a:xfrm>
+          <a:prstGeom prst="roundRect">
+            <a:avLst>
+              <a:gd name="adj" fmla="val 10000"/>
+            </a:avLst>
+          </a:prstGeom>
+          <a:solidFill>
+            <a:srgbClr val="FCF3E6"/>
+          </a:solidFill>
+          <a:ln>
+            <a:noFill/>
+          </a:ln>
+          <a:effectLst/>
+        </p:spPr>
+        <p:style>
+          <a:lnRef idx="1">
+            <a:schemeClr val="accent1"/>
+          </a:lnRef>
+          <a:fillRef idx="3">
+            <a:schemeClr val="accent1"/>
+          </a:fillRef>
+          <a:effectRef idx="2">
+            <a:schemeClr val="accent1"/>
+          </a:effectRef>
+          <a:fontRef idx="minor">
+            <a:schemeClr val="lt1"/>
+          </a:fontRef>
+        </p:style>
+        <p:txBody>
+          <a:bodyPr rtlCol="0" anchor="ctr"/>
+          <a:lstStyle/>
+          <a:p>
+            <a:pPr algn="ctr"/>
+          </a:p>
+        </p:txBody>
+      </p:sp>
+      <p:sp>
+        <p:nvSpPr>
+          <p:cNvPr id="35" name="TextBox 34"/>
+          <p:cNvSpPr txBox="1"/>
+          <p:nvPr/>
+        </p:nvSpPr>
+        <p:spPr>
+          <a:xfrm>
+            <a:off x="4245864" y="3227832"/>
+            <a:ext cx="3669792" cy="310896"/>
+          </a:xfrm>
+          <a:prstGeom prst="rect">
+            <a:avLst/>
+          </a:prstGeom>
+          <a:noFill/>
+        </p:spPr>
+        <p:txBody>
+          <a:bodyPr wrap="square" anchor="ctr" lIns="38100" rIns="38100" tIns="25400" bIns="25400">
+            <a:spAutoFit/>
+          </a:bodyPr>
+          <a:lstStyle/>
+          <a:p>
+            <a:pPr algn="l">
+              <a:lnSpc>
+                <a:spcPct val="110000"/>
+              </a:lnSpc>
+            </a:pPr>
+            <a:r>
+              <a:rPr sz="1050" b="1" i="0">
+                <a:solidFill>
+                  <a:srgbClr val="9A5A00"/>
+                </a:solidFill>
+                <a:latin typeface="Calibri"/>
+                <a:ea typeface="Calibri"/>
+                <a:cs typeface="Calibri"/>
+              </a:rPr>
+              <a:t>C3 · RCPS selection protocol (no training)</a:t>
+            </a:r>
+          </a:p>
+        </p:txBody>
+      </p:sp>
+      <p:sp>
+        <p:nvSpPr>
+          <p:cNvPr id="36" name="TextBox 35"/>
+          <p:cNvSpPr txBox="1"/>
+          <p:nvPr/>
+        </p:nvSpPr>
+        <p:spPr>
+          <a:xfrm>
+            <a:off x="4309872" y="3611879"/>
+            <a:ext cx="3541776" cy="365760"/>
+          </a:xfrm>
+          <a:prstGeom prst="rect">
+            <a:avLst/>
+          </a:prstGeom>
+          <a:noFill/>
+        </p:spPr>
+        <p:txBody>
+          <a:bodyPr wrap="square" anchor="t" lIns="38100" rIns="38100" tIns="25400" bIns="25400">
+            <a:spAutoFit/>
+          </a:bodyPr>
+          <a:lstStyle/>
+          <a:p>
+            <a:pPr algn="l">
+              <a:lnSpc>
+                <a:spcPct val="110000"/>
+              </a:lnSpc>
+            </a:pPr>
+            <a:r>
+              <a:rPr sz="950" b="0" i="0">
+                <a:solidFill>
+                  <a:srgbClr val="202020"/>
+                </a:solidFill>
+                <a:latin typeface="Calibri"/>
+                <a:ea typeface="Calibri"/>
+                <a:cs typeface="Calibri"/>
+              </a:rPr>
+              <a:t>held-out Q–A probe, scored over 3 retrievers:</a:t>
+            </a:r>
+          </a:p>
+        </p:txBody>
+      </p:sp>
       <p:pic>
         <p:nvPicPr>
-          <p:cNvPr id="24" name="Picture 23" descr="fig_coverage.png"/>
+          <p:cNvPr id="37" name="Picture 36" descr="bge_baai.png"/>
           <p:cNvPicPr>
             <a:picLocks noChangeAspect="1"/>
           </p:cNvPicPr>
@@ -4318,252 +4907,17 @@
         </p:blipFill>
         <p:spPr>
           <a:xfrm>
-            <a:off x="4800833" y="1115568"/>
-            <a:ext cx="2559852" cy="1417319"/>
+            <a:off x="4840224" y="3977639"/>
+            <a:ext cx="457200" cy="457200"/>
           </a:xfrm>
           <a:prstGeom prst="rect">
             <a:avLst/>
           </a:prstGeom>
         </p:spPr>
       </p:pic>
-      <p:sp>
-        <p:nvSpPr>
-          <p:cNvPr id="25" name="TextBox 24"/>
-          <p:cNvSpPr txBox="1"/>
-          <p:nvPr/>
-        </p:nvSpPr>
-        <p:spPr>
-          <a:xfrm>
-            <a:off x="4309872" y="2532887"/>
-            <a:ext cx="3541776" cy="502920"/>
-          </a:xfrm>
-          <a:prstGeom prst="rect">
-            <a:avLst/>
-          </a:prstGeom>
-          <a:noFill/>
-        </p:spPr>
-        <p:txBody>
-          <a:bodyPr wrap="square" anchor="t" lIns="38100" rIns="38100" tIns="25400" bIns="25400">
-            <a:spAutoFit/>
-          </a:bodyPr>
-          <a:lstStyle/>
-          <a:p>
-            <a:pPr algn="ctr">
-              <a:lnSpc>
-                <a:spcPct val="110000"/>
-              </a:lnSpc>
-            </a:pPr>
-            <a:r>
-              <a:rPr sz="1050" b="1" i="0">
-                <a:solidFill>
-                  <a:srgbClr val="8F1B1B"/>
-                </a:solidFill>
-                <a:latin typeface="Calibri"/>
-                <a:ea typeface="Calibri"/>
-                <a:cs typeface="Calibri"/>
-              </a:rPr>
-              <a:t>20.2% of answers absent = parser fault</a:t>
-            </a:r>
-          </a:p>
-          <a:p>
-            <a:pPr algn="ctr">
-              <a:lnSpc>
-                <a:spcPct val="110000"/>
-              </a:lnSpc>
-            </a:pPr>
-            <a:r>
-              <a:rPr sz="880" b="0" i="1">
-                <a:solidFill>
-                  <a:srgbClr val="555555"/>
-                </a:solidFill>
-                <a:latin typeface="Calibri"/>
-                <a:ea typeface="Calibri"/>
-                <a:cs typeface="Calibri"/>
-              </a:rPr>
-              <a:t>flat across 8 chunkers → fix the parser, not the chunker</a:t>
-            </a:r>
-          </a:p>
-        </p:txBody>
-      </p:sp>
-      <p:sp>
-        <p:nvSpPr>
-          <p:cNvPr id="26" name="Rounded Rectangle 25"/>
-          <p:cNvSpPr/>
-          <p:nvPr/>
-        </p:nvSpPr>
-        <p:spPr>
-          <a:xfrm>
-            <a:off x="4200144" y="3227832"/>
-            <a:ext cx="3761232" cy="1691640"/>
-          </a:xfrm>
-          <a:prstGeom prst="roundRect">
-            <a:avLst>
-              <a:gd name="adj" fmla="val 4000"/>
-            </a:avLst>
-          </a:prstGeom>
-          <a:solidFill>
-            <a:srgbClr val="FFFFFF"/>
-          </a:solidFill>
-          <a:ln w="15875">
-            <a:solidFill>
-              <a:srgbClr val="9A5A00"/>
-            </a:solidFill>
-          </a:ln>
-          <a:effectLst/>
-        </p:spPr>
-        <p:style>
-          <a:lnRef idx="1">
-            <a:schemeClr val="accent1"/>
-          </a:lnRef>
-          <a:fillRef idx="3">
-            <a:schemeClr val="accent1"/>
-          </a:fillRef>
-          <a:effectRef idx="2">
-            <a:schemeClr val="accent1"/>
-          </a:effectRef>
-          <a:fontRef idx="minor">
-            <a:schemeClr val="lt1"/>
-          </a:fontRef>
-        </p:style>
-        <p:txBody>
-          <a:bodyPr rtlCol="0" anchor="ctr"/>
-          <a:lstStyle/>
-          <a:p>
-            <a:pPr algn="ctr"/>
-          </a:p>
-        </p:txBody>
-      </p:sp>
-      <p:sp>
-        <p:nvSpPr>
-          <p:cNvPr id="27" name="Rounded Rectangle 26"/>
-          <p:cNvSpPr/>
-          <p:nvPr/>
-        </p:nvSpPr>
-        <p:spPr>
-          <a:xfrm>
-            <a:off x="4200144" y="3227832"/>
-            <a:ext cx="3761232" cy="310896"/>
-          </a:xfrm>
-          <a:prstGeom prst="roundRect">
-            <a:avLst>
-              <a:gd name="adj" fmla="val 10000"/>
-            </a:avLst>
-          </a:prstGeom>
-          <a:solidFill>
-            <a:srgbClr val="FCF3E6"/>
-          </a:solidFill>
-          <a:ln>
-            <a:noFill/>
-          </a:ln>
-          <a:effectLst/>
-        </p:spPr>
-        <p:style>
-          <a:lnRef idx="1">
-            <a:schemeClr val="accent1"/>
-          </a:lnRef>
-          <a:fillRef idx="3">
-            <a:schemeClr val="accent1"/>
-          </a:fillRef>
-          <a:effectRef idx="2">
-            <a:schemeClr val="accent1"/>
-          </a:effectRef>
-          <a:fontRef idx="minor">
-            <a:schemeClr val="lt1"/>
-          </a:fontRef>
-        </p:style>
-        <p:txBody>
-          <a:bodyPr rtlCol="0" anchor="ctr"/>
-          <a:lstStyle/>
-          <a:p>
-            <a:pPr algn="ctr"/>
-          </a:p>
-        </p:txBody>
-      </p:sp>
-      <p:sp>
-        <p:nvSpPr>
-          <p:cNvPr id="28" name="TextBox 27"/>
-          <p:cNvSpPr txBox="1"/>
-          <p:nvPr/>
-        </p:nvSpPr>
-        <p:spPr>
-          <a:xfrm>
-            <a:off x="4245864" y="3227832"/>
-            <a:ext cx="3669792" cy="310896"/>
-          </a:xfrm>
-          <a:prstGeom prst="rect">
-            <a:avLst/>
-          </a:prstGeom>
-          <a:noFill/>
-        </p:spPr>
-        <p:txBody>
-          <a:bodyPr wrap="square" anchor="ctr" lIns="38100" rIns="38100" tIns="25400" bIns="25400">
-            <a:spAutoFit/>
-          </a:bodyPr>
-          <a:lstStyle/>
-          <a:p>
-            <a:pPr algn="l">
-              <a:lnSpc>
-                <a:spcPct val="110000"/>
-              </a:lnSpc>
-            </a:pPr>
-            <a:r>
-              <a:rPr sz="1050" b="1" i="0">
-                <a:solidFill>
-                  <a:srgbClr val="9A5A00"/>
-                </a:solidFill>
-                <a:latin typeface="Calibri"/>
-                <a:ea typeface="Calibri"/>
-                <a:cs typeface="Calibri"/>
-              </a:rPr>
-              <a:t>C3 · RCPS selection protocol (no training)</a:t>
-            </a:r>
-          </a:p>
-        </p:txBody>
-      </p:sp>
-      <p:sp>
-        <p:nvSpPr>
-          <p:cNvPr id="29" name="TextBox 28"/>
-          <p:cNvSpPr txBox="1"/>
-          <p:nvPr/>
-        </p:nvSpPr>
-        <p:spPr>
-          <a:xfrm>
-            <a:off x="4309872" y="3611879"/>
-            <a:ext cx="3541776" cy="365760"/>
-          </a:xfrm>
-          <a:prstGeom prst="rect">
-            <a:avLst/>
-          </a:prstGeom>
-          <a:noFill/>
-        </p:spPr>
-        <p:txBody>
-          <a:bodyPr wrap="square" anchor="t" lIns="38100" rIns="38100" tIns="25400" bIns="25400">
-            <a:spAutoFit/>
-          </a:bodyPr>
-          <a:lstStyle/>
-          <a:p>
-            <a:pPr algn="l">
-              <a:lnSpc>
-                <a:spcPct val="110000"/>
-              </a:lnSpc>
-            </a:pPr>
-            <a:r>
-              <a:rPr sz="950" b="0" i="0">
-                <a:solidFill>
-                  <a:srgbClr val="202020"/>
-                </a:solidFill>
-                <a:latin typeface="Calibri"/>
-                <a:ea typeface="Calibri"/>
-                <a:cs typeface="Calibri"/>
-              </a:rPr>
-              <a:t>held-out Q–A probe, scored over 3 retrievers:</a:t>
-            </a:r>
-          </a:p>
-        </p:txBody>
-      </p:sp>
       <p:pic>
         <p:nvPicPr>
-          <p:cNvPr id="30" name="Picture 29" descr="bge_baai.png"/>
+          <p:cNvPr id="38" name="Picture 37" descr="me5_ms.png"/>
           <p:cNvPicPr>
             <a:picLocks noChangeAspect="1"/>
           </p:cNvPicPr>
@@ -4577,7 +4931,7 @@
         </p:blipFill>
         <p:spPr>
           <a:xfrm>
-            <a:off x="4840224" y="3977639"/>
+            <a:off x="5891784" y="3977639"/>
             <a:ext cx="457200" cy="457200"/>
           </a:xfrm>
           <a:prstGeom prst="rect">
@@ -4587,31 +4941,7 @@
       </p:pic>
       <p:pic>
         <p:nvPicPr>
-          <p:cNvPr id="31" name="Picture 30" descr="me5_ms.png"/>
-          <p:cNvPicPr>
-            <a:picLocks noChangeAspect="1"/>
-          </p:cNvPicPr>
-          <p:nvPr/>
-        </p:nvPicPr>
-        <p:blipFill>
-          <a:blip r:embed="rId8"/>
-          <a:stretch>
-            <a:fillRect/>
-          </a:stretch>
-        </p:blipFill>
-        <p:spPr>
-          <a:xfrm>
-            <a:off x="5891784" y="3977639"/>
-            <a:ext cx="457200" cy="457200"/>
-          </a:xfrm>
-          <a:prstGeom prst="rect">
-            <a:avLst/>
-          </a:prstGeom>
-        </p:spPr>
-      </p:pic>
-      <p:pic>
-        <p:nvPicPr>
-          <p:cNvPr id="32" name="Picture 31" descr="qwen.png"/>
+          <p:cNvPr id="39" name="Picture 38" descr="qwen.png"/>
           <p:cNvPicPr>
             <a:picLocks noChangeAspect="1"/>
           </p:cNvPicPr>
@@ -4635,7 +4965,7 @@
       </p:pic>
       <p:sp>
         <p:nvSpPr>
-          <p:cNvPr id="33" name="TextBox 32"/>
+          <p:cNvPr id="40" name="TextBox 39"/>
           <p:cNvSpPr txBox="1"/>
           <p:nvPr/>
         </p:nvSpPr>
@@ -4676,7 +5006,7 @@
       </p:sp>
       <p:sp>
         <p:nvSpPr>
-          <p:cNvPr id="34" name="TextBox 33"/>
+          <p:cNvPr id="41" name="TextBox 40"/>
           <p:cNvSpPr txBox="1"/>
           <p:nvPr/>
         </p:nvSpPr>
@@ -4717,7 +5047,7 @@
       </p:sp>
       <p:sp>
         <p:nvSpPr>
-          <p:cNvPr id="35" name="Rounded Rectangle 34"/>
+          <p:cNvPr id="42" name="Rounded Rectangle 41"/>
           <p:cNvSpPr/>
           <p:nvPr/>
         </p:nvSpPr>
@@ -4765,7 +5095,7 @@
       </p:sp>
       <p:sp>
         <p:nvSpPr>
-          <p:cNvPr id="36" name="Rounded Rectangle 35"/>
+          <p:cNvPr id="43" name="Rounded Rectangle 42"/>
           <p:cNvSpPr/>
           <p:nvPr/>
         </p:nvSpPr>
@@ -4811,7 +5141,7 @@
       </p:sp>
       <p:sp>
         <p:nvSpPr>
-          <p:cNvPr id="37" name="TextBox 36"/>
+          <p:cNvPr id="44" name="TextBox 43"/>
           <p:cNvSpPr txBox="1"/>
           <p:nvPr/>
         </p:nvSpPr>
@@ -4852,7 +5182,7 @@
       </p:sp>
       <p:sp>
         <p:nvSpPr>
-          <p:cNvPr id="38" name="TextBox 37"/>
+          <p:cNvPr id="45" name="TextBox 44"/>
           <p:cNvSpPr txBox="1"/>
           <p:nvPr/>
         </p:nvSpPr>
@@ -4893,7 +5223,7 @@
       </p:sp>
       <p:sp>
         <p:nvSpPr>
-          <p:cNvPr id="39" name="Rounded Rectangle 38"/>
+          <p:cNvPr id="46" name="Rounded Rectangle 45"/>
           <p:cNvSpPr/>
           <p:nvPr/>
         </p:nvSpPr>
@@ -4941,7 +5271,7 @@
       </p:sp>
       <p:sp>
         <p:nvSpPr>
-          <p:cNvPr id="40" name="TextBox 39"/>
+          <p:cNvPr id="47" name="TextBox 46"/>
           <p:cNvSpPr txBox="1"/>
           <p:nvPr/>
         </p:nvSpPr>
@@ -4982,7 +5312,7 @@
       </p:sp>
       <p:sp>
         <p:nvSpPr>
-          <p:cNvPr id="41" name="TextBox 40"/>
+          <p:cNvPr id="48" name="TextBox 47"/>
           <p:cNvSpPr txBox="1"/>
           <p:nvPr/>
         </p:nvSpPr>
@@ -5023,7 +5353,7 @@
       </p:sp>
       <p:sp>
         <p:nvSpPr>
-          <p:cNvPr id="42" name="Rounded Rectangle 41"/>
+          <p:cNvPr id="49" name="Rounded Rectangle 48"/>
           <p:cNvSpPr/>
           <p:nvPr/>
         </p:nvSpPr>
@@ -5071,7 +5401,7 @@
       </p:sp>
       <p:sp>
         <p:nvSpPr>
-          <p:cNvPr id="43" name="TextBox 42"/>
+          <p:cNvPr id="50" name="TextBox 49"/>
           <p:cNvSpPr txBox="1"/>
           <p:nvPr/>
         </p:nvSpPr>
@@ -5112,7 +5442,7 @@
       </p:sp>
       <p:sp>
         <p:nvSpPr>
-          <p:cNvPr id="44" name="Rounded Rectangle 43"/>
+          <p:cNvPr id="51" name="Rounded Rectangle 50"/>
           <p:cNvSpPr/>
           <p:nvPr/>
         </p:nvSpPr>
@@ -5160,7 +5490,7 @@
       </p:sp>
       <p:sp>
         <p:nvSpPr>
-          <p:cNvPr id="45" name="Rounded Rectangle 44"/>
+          <p:cNvPr id="52" name="Rounded Rectangle 51"/>
           <p:cNvSpPr/>
           <p:nvPr/>
         </p:nvSpPr>
@@ -5206,7 +5536,7 @@
       </p:sp>
       <p:sp>
         <p:nvSpPr>
-          <p:cNvPr id="46" name="TextBox 45"/>
+          <p:cNvPr id="53" name="TextBox 52"/>
           <p:cNvSpPr txBox="1"/>
           <p:nvPr/>
         </p:nvSpPr>
@@ -5245,40 +5575,16 @@
           </a:p>
         </p:txBody>
       </p:sp>
-      <p:pic>
-        <p:nvPicPr>
-          <p:cNvPr id="47" name="Picture 46" descr="fig_c4_training.png"/>
-          <p:cNvPicPr>
-            <a:picLocks noChangeAspect="1"/>
-          </p:cNvPicPr>
-          <p:nvPr/>
-        </p:nvPicPr>
-        <p:blipFill>
-          <a:blip r:embed="rId9"/>
-          <a:stretch>
-            <a:fillRect/>
-          </a:stretch>
-        </p:blipFill>
-        <p:spPr>
-          <a:xfrm>
-            <a:off x="8729359" y="3044952"/>
-            <a:ext cx="2700753" cy="1325880"/>
-          </a:xfrm>
-          <a:prstGeom prst="rect">
-            <a:avLst/>
-          </a:prstGeom>
-        </p:spPr>
-      </p:pic>
-      <p:sp>
-        <p:nvSpPr>
-          <p:cNvPr id="48" name="TextBox 47"/>
+      <p:sp>
+        <p:nvSpPr>
+          <p:cNvPr id="54" name="TextBox 53"/>
           <p:cNvSpPr txBox="1"/>
           <p:nvPr/>
         </p:nvSpPr>
         <p:spPr>
           <a:xfrm>
-            <a:off x="8308848" y="4370832"/>
-            <a:ext cx="3541776" cy="502920"/>
+            <a:off x="8327136" y="3063240"/>
+            <a:ext cx="3505200" cy="274320"/>
           </a:xfrm>
           <a:prstGeom prst="rect">
             <a:avLst/>
@@ -5291,13 +5597,328 @@
           </a:bodyPr>
           <a:lstStyle/>
           <a:p>
-            <a:pPr algn="ctr">
+            <a:pPr algn="l">
               <a:lnSpc>
                 <a:spcPct val="110000"/>
               </a:lnSpc>
             </a:pPr>
             <a:r>
+              <a:rPr sz="950" b="0" i="0">
+                <a:solidFill>
+                  <a:srgbClr val="202020"/>
+                </a:solidFill>
+                <a:latin typeface="Calibri"/>
+                <a:ea typeface="Calibri"/>
+                <a:cs typeface="Calibri"/>
+              </a:rPr>
+              <a:t>Hit@5 gain over the untuned parser:</a:t>
+            </a:r>
+          </a:p>
+        </p:txBody>
+      </p:sp>
+      <p:sp>
+        <p:nvSpPr>
+          <p:cNvPr id="55" name="TextBox 54"/>
+          <p:cNvSpPr txBox="1"/>
+          <p:nvPr/>
+        </p:nvSpPr>
+        <p:spPr>
+          <a:xfrm>
+            <a:off x="8345424" y="3520440"/>
+            <a:ext cx="1115568" cy="292608"/>
+          </a:xfrm>
+          <a:prstGeom prst="rect">
+            <a:avLst/>
+          </a:prstGeom>
+          <a:noFill/>
+        </p:spPr>
+        <p:txBody>
+          <a:bodyPr wrap="square" anchor="ctr" lIns="38100" rIns="38100" tIns="25400" bIns="25400">
+            <a:spAutoFit/>
+          </a:bodyPr>
+          <a:lstStyle/>
+          <a:p>
+            <a:pPr algn="l">
+              <a:lnSpc>
+                <a:spcPct val="110000"/>
+              </a:lnSpc>
+            </a:pPr>
+            <a:r>
+              <a:rPr sz="900" b="1" i="0">
+                <a:solidFill>
+                  <a:srgbClr val="4A9A4A"/>
+                </a:solidFill>
+                <a:latin typeface="Calibri"/>
+                <a:ea typeface="Calibri"/>
+                <a:cs typeface="Calibri"/>
+              </a:rPr>
+              <a:t>RADP-Distill</a:t>
+            </a:r>
+          </a:p>
+        </p:txBody>
+      </p:sp>
+      <p:sp>
+        <p:nvSpPr>
+          <p:cNvPr id="56" name="Rectangle 55"/>
+          <p:cNvSpPr/>
+          <p:nvPr/>
+        </p:nvSpPr>
+        <p:spPr>
+          <a:xfrm>
+            <a:off x="9497568" y="3547872"/>
+            <a:ext cx="1325880" cy="274320"/>
+          </a:xfrm>
+          <a:prstGeom prst="rect">
+            <a:avLst/>
+          </a:prstGeom>
+          <a:solidFill>
+            <a:srgbClr val="4A9A4A"/>
+          </a:solidFill>
+          <a:ln w="9525">
+            <a:solidFill>
+              <a:srgbClr val="FFFFFF"/>
+            </a:solidFill>
+          </a:ln>
+          <a:effectLst/>
+        </p:spPr>
+        <p:style>
+          <a:lnRef idx="1">
+            <a:schemeClr val="accent1"/>
+          </a:lnRef>
+          <a:fillRef idx="3">
+            <a:schemeClr val="accent1"/>
+          </a:fillRef>
+          <a:effectRef idx="2">
+            <a:schemeClr val="accent1"/>
+          </a:effectRef>
+          <a:fontRef idx="minor">
+            <a:schemeClr val="lt1"/>
+          </a:fontRef>
+        </p:style>
+        <p:txBody>
+          <a:bodyPr rtlCol="0" anchor="ctr"/>
+          <a:lstStyle/>
+          <a:p>
+            <a:pPr algn="ctr"/>
+          </a:p>
+        </p:txBody>
+      </p:sp>
+      <p:sp>
+        <p:nvSpPr>
+          <p:cNvPr id="57" name="TextBox 56"/>
+          <p:cNvSpPr txBox="1"/>
+          <p:nvPr/>
+        </p:nvSpPr>
+        <p:spPr>
+          <a:xfrm>
+            <a:off x="10869168" y="3520440"/>
+            <a:ext cx="777240" cy="292608"/>
+          </a:xfrm>
+          <a:prstGeom prst="rect">
+            <a:avLst/>
+          </a:prstGeom>
+          <a:noFill/>
+        </p:spPr>
+        <p:txBody>
+          <a:bodyPr wrap="square" anchor="ctr" lIns="38100" rIns="38100" tIns="25400" bIns="25400">
+            <a:spAutoFit/>
+          </a:bodyPr>
+          <a:lstStyle/>
+          <a:p>
+            <a:pPr algn="l">
+              <a:lnSpc>
+                <a:spcPct val="110000"/>
+              </a:lnSpc>
+            </a:pPr>
+            <a:r>
               <a:rPr sz="950" b="1" i="0">
+                <a:solidFill>
+                  <a:srgbClr val="202020"/>
+                </a:solidFill>
+                <a:latin typeface="Calibri"/>
+                <a:ea typeface="Calibri"/>
+                <a:cs typeface="Calibri"/>
+              </a:rPr>
+              <a:t>+1.22 pp</a:t>
+            </a:r>
+          </a:p>
+        </p:txBody>
+      </p:sp>
+      <p:sp>
+        <p:nvSpPr>
+          <p:cNvPr id="58" name="TextBox 57"/>
+          <p:cNvSpPr txBox="1"/>
+          <p:nvPr/>
+        </p:nvSpPr>
+        <p:spPr>
+          <a:xfrm>
+            <a:off x="8345424" y="3950207"/>
+            <a:ext cx="1115568" cy="292608"/>
+          </a:xfrm>
+          <a:prstGeom prst="rect">
+            <a:avLst/>
+          </a:prstGeom>
+          <a:noFill/>
+        </p:spPr>
+        <p:txBody>
+          <a:bodyPr wrap="square" anchor="ctr" lIns="38100" rIns="38100" tIns="25400" bIns="25400">
+            <a:spAutoFit/>
+          </a:bodyPr>
+          <a:lstStyle/>
+          <a:p>
+            <a:pPr algn="l">
+              <a:lnSpc>
+                <a:spcPct val="110000"/>
+              </a:lnSpc>
+            </a:pPr>
+            <a:r>
+              <a:rPr sz="900" b="1" i="0">
+                <a:solidFill>
+                  <a:srgbClr val="D98A2B"/>
+                </a:solidFill>
+                <a:latin typeface="Calibri"/>
+                <a:ea typeface="Calibri"/>
+                <a:cs typeface="Calibri"/>
+              </a:rPr>
+              <a:t>RADP-DPO</a:t>
+            </a:r>
+          </a:p>
+        </p:txBody>
+      </p:sp>
+      <p:sp>
+        <p:nvSpPr>
+          <p:cNvPr id="59" name="Rectangle 58"/>
+          <p:cNvSpPr/>
+          <p:nvPr/>
+        </p:nvSpPr>
+        <p:spPr>
+          <a:xfrm>
+            <a:off x="9497568" y="3977639"/>
+            <a:ext cx="923768" cy="274320"/>
+          </a:xfrm>
+          <a:prstGeom prst="rect">
+            <a:avLst/>
+          </a:prstGeom>
+          <a:solidFill>
+            <a:srgbClr val="D98A2B"/>
+          </a:solidFill>
+          <a:ln w="9525">
+            <a:solidFill>
+              <a:srgbClr val="FFFFFF"/>
+            </a:solidFill>
+          </a:ln>
+          <a:effectLst/>
+        </p:spPr>
+        <p:style>
+          <a:lnRef idx="1">
+            <a:schemeClr val="accent1"/>
+          </a:lnRef>
+          <a:fillRef idx="3">
+            <a:schemeClr val="accent1"/>
+          </a:fillRef>
+          <a:effectRef idx="2">
+            <a:schemeClr val="accent1"/>
+          </a:effectRef>
+          <a:fontRef idx="minor">
+            <a:schemeClr val="lt1"/>
+          </a:fontRef>
+        </p:style>
+        <p:txBody>
+          <a:bodyPr rtlCol="0" anchor="ctr"/>
+          <a:lstStyle/>
+          <a:p>
+            <a:pPr algn="ctr"/>
+          </a:p>
+        </p:txBody>
+      </p:sp>
+      <p:sp>
+        <p:nvSpPr>
+          <p:cNvPr id="60" name="TextBox 59"/>
+          <p:cNvSpPr txBox="1"/>
+          <p:nvPr/>
+        </p:nvSpPr>
+        <p:spPr>
+          <a:xfrm>
+            <a:off x="10467056" y="3950207"/>
+            <a:ext cx="777240" cy="292608"/>
+          </a:xfrm>
+          <a:prstGeom prst="rect">
+            <a:avLst/>
+          </a:prstGeom>
+          <a:noFill/>
+        </p:spPr>
+        <p:txBody>
+          <a:bodyPr wrap="square" anchor="ctr" lIns="38100" rIns="38100" tIns="25400" bIns="25400">
+            <a:spAutoFit/>
+          </a:bodyPr>
+          <a:lstStyle/>
+          <a:p>
+            <a:pPr algn="l">
+              <a:lnSpc>
+                <a:spcPct val="110000"/>
+              </a:lnSpc>
+            </a:pPr>
+            <a:r>
+              <a:rPr sz="950" b="1" i="0">
+                <a:solidFill>
+                  <a:srgbClr val="202020"/>
+                </a:solidFill>
+                <a:latin typeface="Calibri"/>
+                <a:ea typeface="Calibri"/>
+                <a:cs typeface="Calibri"/>
+              </a:rPr>
+              <a:t>+0.85 pp</a:t>
+            </a:r>
+          </a:p>
+        </p:txBody>
+      </p:sp>
+      <p:sp>
+        <p:nvSpPr>
+          <p:cNvPr id="61" name="TextBox 60"/>
+          <p:cNvSpPr txBox="1"/>
+          <p:nvPr/>
+        </p:nvSpPr>
+        <p:spPr>
+          <a:xfrm>
+            <a:off x="8327136" y="4315968"/>
+            <a:ext cx="3505200" cy="548640"/>
+          </a:xfrm>
+          <a:prstGeom prst="rect">
+            <a:avLst/>
+          </a:prstGeom>
+          <a:noFill/>
+        </p:spPr>
+        <p:txBody>
+          <a:bodyPr wrap="square" anchor="t" lIns="38100" rIns="38100" tIns="25400" bIns="25400">
+            <a:spAutoFit/>
+          </a:bodyPr>
+          <a:lstStyle/>
+          <a:p>
+            <a:pPr algn="ctr">
+              <a:lnSpc>
+                <a:spcPct val="128000"/>
+              </a:lnSpc>
+            </a:pPr>
+            <a:r>
+              <a:rPr sz="950" b="1" i="0">
+                <a:solidFill>
+                  <a:srgbClr val="202020"/>
+                </a:solidFill>
+                <a:latin typeface="Calibri"/>
+                <a:ea typeface="Calibri"/>
+                <a:cs typeface="Calibri"/>
+              </a:rPr>
+              <a:t>≈  overlapping CIs → equal gain</a:t>
+            </a:r>
+          </a:p>
+          <a:p>
+            <a:pPr algn="ctr">
+              <a:lnSpc>
+                <a:spcPct val="128000"/>
+              </a:lnSpc>
+            </a:pPr>
+            <a:r>
+              <a:rPr sz="900" b="1" i="0">
                 <a:solidFill>
                   <a:srgbClr val="1A6B1A"/>
                 </a:solidFill>
@@ -5305,32 +5926,14 @@
                 <a:ea typeface="Calibri"/>
                 <a:cs typeface="Calibri"/>
               </a:rPr>
-              <a:t>the two signals tie → retrieval reward unnecessary</a:t>
-            </a:r>
-          </a:p>
-          <a:p>
-            <a:pPr algn="ctr">
-              <a:lnSpc>
-                <a:spcPct val="110000"/>
-              </a:lnSpc>
-            </a:pPr>
-            <a:r>
-              <a:rPr sz="880" b="0" i="1">
-                <a:solidFill>
-                  <a:srgbClr val="555555"/>
-                </a:solidFill>
-                <a:latin typeface="Calibri"/>
-                <a:ea typeface="Calibri"/>
-                <a:cs typeface="Calibri"/>
-              </a:rPr>
-              <a:t>the deployable lever is fidelity distillation</a:t>
-            </a:r>
-          </a:p>
-        </p:txBody>
-      </p:sp>
-      <p:sp>
-        <p:nvSpPr>
-          <p:cNvPr id="49" name="Chevron 48"/>
+              <a:t>retrieval reward unnecessary; lever = fidelity distillation</a:t>
+            </a:r>
+          </a:p>
+        </p:txBody>
+      </p:sp>
+      <p:sp>
+        <p:nvSpPr>
+          <p:cNvPr id="62" name="Chevron 61"/>
           <p:cNvSpPr/>
           <p:nvPr/>
         </p:nvSpPr>
@@ -5374,7 +5977,7 @@
       </p:sp>
       <p:sp>
         <p:nvSpPr>
-          <p:cNvPr id="50" name="Chevron 49"/>
+          <p:cNvPr id="63" name="Chevron 62"/>
           <p:cNvSpPr/>
           <p:nvPr/>
         </p:nvSpPr>

</xml_diff>

<commit_message>
fig: overview — drop stray '+GOT', label each logo under it
C1 candidate parsers: remove the odd '+ GOT' text among the logos; put each
parser name (Qwen3-VL / MinerU / Marker / PaddleOCR) under its logo. C3:
replace the single centered 'BGE-M3 · mE5 · Qwen3-Emb' caption with per-logo
labels aligned directly under each retriever logo.
</commit_message>
<xml_diff>
--- a/paper/figures/fig_overview.pptx
+++ b/paper/figures/fig_overview.pptx
@@ -3358,7 +3358,7 @@
         <p:spPr>
           <a:xfrm>
             <a:off x="201168" y="749808"/>
-            <a:ext cx="3761232" cy="868680"/>
+            <a:ext cx="3761232" cy="1078992"/>
           </a:xfrm>
           <a:prstGeom prst="roundRect">
             <a:avLst>
@@ -3500,17 +3500,58 @@
         </p:blipFill>
         <p:spPr>
           <a:xfrm>
-            <a:off x="457200" y="1133856"/>
-            <a:ext cx="420624" cy="420624"/>
+            <a:off x="612648" y="1115568"/>
+            <a:ext cx="384048" cy="384048"/>
           </a:xfrm>
           <a:prstGeom prst="rect">
             <a:avLst/>
           </a:prstGeom>
         </p:spPr>
       </p:pic>
+      <p:sp>
+        <p:nvSpPr>
+          <p:cNvPr id="12" name="TextBox 11"/>
+          <p:cNvSpPr txBox="1"/>
+          <p:nvPr/>
+        </p:nvSpPr>
+        <p:spPr>
+          <a:xfrm>
+            <a:off x="365760" y="1536192"/>
+            <a:ext cx="877824" cy="219456"/>
+          </a:xfrm>
+          <a:prstGeom prst="rect">
+            <a:avLst/>
+          </a:prstGeom>
+          <a:noFill/>
+        </p:spPr>
+        <p:txBody>
+          <a:bodyPr wrap="square" anchor="t" lIns="38100" rIns="38100" tIns="25400" bIns="25400">
+            <a:spAutoFit/>
+          </a:bodyPr>
+          <a:lstStyle/>
+          <a:p>
+            <a:pPr algn="ctr">
+              <a:lnSpc>
+                <a:spcPct val="110000"/>
+              </a:lnSpc>
+            </a:pPr>
+            <a:r>
+              <a:rPr sz="750" b="0" i="0">
+                <a:solidFill>
+                  <a:srgbClr val="555555"/>
+                </a:solidFill>
+                <a:latin typeface="Calibri"/>
+                <a:ea typeface="Calibri"/>
+                <a:cs typeface="Calibri"/>
+              </a:rPr>
+              <a:t>Qwen3-VL</a:t>
+            </a:r>
+          </a:p>
+        </p:txBody>
+      </p:sp>
       <p:pic>
         <p:nvPicPr>
-          <p:cNvPr id="12" name="Picture 11" descr="mineru.png"/>
+          <p:cNvPr id="13" name="Picture 12" descr="mineru.png"/>
           <p:cNvPicPr>
             <a:picLocks noChangeAspect="1"/>
           </p:cNvPicPr>
@@ -3524,17 +3565,58 @@
         </p:blipFill>
         <p:spPr>
           <a:xfrm>
-            <a:off x="1133856" y="1133856"/>
-            <a:ext cx="420624" cy="420624"/>
+            <a:off x="1435608" y="1115568"/>
+            <a:ext cx="384048" cy="384048"/>
           </a:xfrm>
           <a:prstGeom prst="rect">
             <a:avLst/>
           </a:prstGeom>
         </p:spPr>
       </p:pic>
+      <p:sp>
+        <p:nvSpPr>
+          <p:cNvPr id="14" name="TextBox 13"/>
+          <p:cNvSpPr txBox="1"/>
+          <p:nvPr/>
+        </p:nvSpPr>
+        <p:spPr>
+          <a:xfrm>
+            <a:off x="1188720" y="1536192"/>
+            <a:ext cx="877824" cy="219456"/>
+          </a:xfrm>
+          <a:prstGeom prst="rect">
+            <a:avLst/>
+          </a:prstGeom>
+          <a:noFill/>
+        </p:spPr>
+        <p:txBody>
+          <a:bodyPr wrap="square" anchor="t" lIns="38100" rIns="38100" tIns="25400" bIns="25400">
+            <a:spAutoFit/>
+          </a:bodyPr>
+          <a:lstStyle/>
+          <a:p>
+            <a:pPr algn="ctr">
+              <a:lnSpc>
+                <a:spcPct val="110000"/>
+              </a:lnSpc>
+            </a:pPr>
+            <a:r>
+              <a:rPr sz="750" b="0" i="0">
+                <a:solidFill>
+                  <a:srgbClr val="555555"/>
+                </a:solidFill>
+                <a:latin typeface="Calibri"/>
+                <a:ea typeface="Calibri"/>
+                <a:cs typeface="Calibri"/>
+              </a:rPr>
+              <a:t>MinerU</a:t>
+            </a:r>
+          </a:p>
+        </p:txBody>
+      </p:sp>
       <p:pic>
         <p:nvPicPr>
-          <p:cNvPr id="13" name="Picture 12" descr="marker_datalab.png"/>
+          <p:cNvPr id="15" name="Picture 14" descr="marker_datalab.png"/>
           <p:cNvPicPr>
             <a:picLocks noChangeAspect="1"/>
           </p:cNvPicPr>
@@ -3548,17 +3630,58 @@
         </p:blipFill>
         <p:spPr>
           <a:xfrm>
-            <a:off x="1810512" y="1133856"/>
-            <a:ext cx="420624" cy="420624"/>
+            <a:off x="2258568" y="1115568"/>
+            <a:ext cx="384048" cy="384048"/>
           </a:xfrm>
           <a:prstGeom prst="rect">
             <a:avLst/>
           </a:prstGeom>
         </p:spPr>
       </p:pic>
+      <p:sp>
+        <p:nvSpPr>
+          <p:cNvPr id="16" name="TextBox 15"/>
+          <p:cNvSpPr txBox="1"/>
+          <p:nvPr/>
+        </p:nvSpPr>
+        <p:spPr>
+          <a:xfrm>
+            <a:off x="2011680" y="1536192"/>
+            <a:ext cx="877824" cy="219456"/>
+          </a:xfrm>
+          <a:prstGeom prst="rect">
+            <a:avLst/>
+          </a:prstGeom>
+          <a:noFill/>
+        </p:spPr>
+        <p:txBody>
+          <a:bodyPr wrap="square" anchor="t" lIns="38100" rIns="38100" tIns="25400" bIns="25400">
+            <a:spAutoFit/>
+          </a:bodyPr>
+          <a:lstStyle/>
+          <a:p>
+            <a:pPr algn="ctr">
+              <a:lnSpc>
+                <a:spcPct val="110000"/>
+              </a:lnSpc>
+            </a:pPr>
+            <a:r>
+              <a:rPr sz="750" b="0" i="0">
+                <a:solidFill>
+                  <a:srgbClr val="555555"/>
+                </a:solidFill>
+                <a:latin typeface="Calibri"/>
+                <a:ea typeface="Calibri"/>
+                <a:cs typeface="Calibri"/>
+              </a:rPr>
+              <a:t>Marker</a:t>
+            </a:r>
+          </a:p>
+        </p:txBody>
+      </p:sp>
       <p:pic>
         <p:nvPicPr>
-          <p:cNvPr id="14" name="Picture 13" descr="paddle.png"/>
+          <p:cNvPr id="17" name="Picture 16" descr="paddle.png"/>
           <p:cNvPicPr>
             <a:picLocks noChangeAspect="1"/>
           </p:cNvPicPr>
@@ -3572,8 +3695,8 @@
         </p:blipFill>
         <p:spPr>
           <a:xfrm>
-            <a:off x="2487168" y="1133856"/>
-            <a:ext cx="420624" cy="420624"/>
+            <a:off x="3081528" y="1115568"/>
+            <a:ext cx="384048" cy="384048"/>
           </a:xfrm>
           <a:prstGeom prst="rect">
             <a:avLst/>
@@ -3582,14 +3705,14 @@
       </p:pic>
       <p:sp>
         <p:nvSpPr>
-          <p:cNvPr id="15" name="TextBox 14"/>
+          <p:cNvPr id="18" name="TextBox 17"/>
           <p:cNvSpPr txBox="1"/>
           <p:nvPr/>
         </p:nvSpPr>
         <p:spPr>
           <a:xfrm>
-            <a:off x="2990088" y="1133856"/>
-            <a:ext cx="880872" cy="420624"/>
+            <a:off x="2834640" y="1536192"/>
+            <a:ext cx="877824" cy="219456"/>
           </a:xfrm>
           <a:prstGeom prst="rect">
             <a:avLst/>
@@ -3597,18 +3720,18 @@
           <a:noFill/>
         </p:spPr>
         <p:txBody>
-          <a:bodyPr wrap="square" anchor="ctr" lIns="38100" rIns="38100" tIns="25400" bIns="25400">
+          <a:bodyPr wrap="square" anchor="t" lIns="38100" rIns="38100" tIns="25400" bIns="25400">
             <a:spAutoFit/>
           </a:bodyPr>
           <a:lstStyle/>
           <a:p>
-            <a:pPr algn="l">
+            <a:pPr algn="ctr">
               <a:lnSpc>
                 <a:spcPct val="110000"/>
               </a:lnSpc>
             </a:pPr>
             <a:r>
-              <a:rPr sz="1000" b="0" i="1">
+              <a:rPr sz="750" b="0" i="0">
                 <a:solidFill>
                   <a:srgbClr val="555555"/>
                 </a:solidFill>
@@ -3616,20 +3739,20 @@
                 <a:ea typeface="Calibri"/>
                 <a:cs typeface="Calibri"/>
               </a:rPr>
-              <a:t>+ GOT</a:t>
-            </a:r>
-          </a:p>
-        </p:txBody>
-      </p:sp>
-      <p:sp>
-        <p:nvSpPr>
-          <p:cNvPr id="16" name="Rounded Rectangle 15"/>
+              <a:t>PaddleOCR</a:t>
+            </a:r>
+          </a:p>
+        </p:txBody>
+      </p:sp>
+      <p:sp>
+        <p:nvSpPr>
+          <p:cNvPr id="19" name="Rounded Rectangle 18"/>
           <p:cNvSpPr/>
           <p:nvPr/>
         </p:nvSpPr>
         <p:spPr>
           <a:xfrm>
-            <a:off x="201168" y="1764792"/>
+            <a:off x="201168" y="1975104"/>
             <a:ext cx="3761232" cy="3108960"/>
           </a:xfrm>
           <a:prstGeom prst="roundRect">
@@ -3671,13 +3794,13 @@
       </p:sp>
       <p:sp>
         <p:nvSpPr>
-          <p:cNvPr id="17" name="Rounded Rectangle 16"/>
+          <p:cNvPr id="20" name="Rounded Rectangle 19"/>
           <p:cNvSpPr/>
           <p:nvPr/>
         </p:nvSpPr>
         <p:spPr>
           <a:xfrm>
-            <a:off x="201168" y="1764792"/>
+            <a:off x="201168" y="1975104"/>
             <a:ext cx="3761232" cy="310896"/>
           </a:xfrm>
           <a:prstGeom prst="roundRect">
@@ -3717,13 +3840,13 @@
       </p:sp>
       <p:sp>
         <p:nvSpPr>
-          <p:cNvPr id="18" name="TextBox 17"/>
+          <p:cNvPr id="21" name="TextBox 20"/>
           <p:cNvSpPr txBox="1"/>
           <p:nvPr/>
         </p:nvSpPr>
         <p:spPr>
           <a:xfrm>
-            <a:off x="246888" y="1764792"/>
+            <a:off x="246888" y="1975104"/>
             <a:ext cx="3669792" cy="310896"/>
           </a:xfrm>
           <a:prstGeom prst="rect">
@@ -3758,14 +3881,14 @@
       </p:sp>
       <p:graphicFrame>
         <p:nvGraphicFramePr>
-          <p:cNvPr id="19" name="Table 18"/>
+          <p:cNvPr id="22" name="Table 21"/>
           <p:cNvGraphicFramePr>
             <a:graphicFrameLocks noGrp="1"/>
           </p:cNvGraphicFramePr>
           <p:nvPr/>
         </p:nvGraphicFramePr>
         <p:xfrm>
-          <a:off x="384048" y="2267712"/>
+          <a:off x="384048" y="2478024"/>
           <a:ext cx="3395470" cy="1554480"/>
         </p:xfrm>
         <a:graphic>
@@ -4092,13 +4215,13 @@
       </p:graphicFrame>
       <p:sp>
         <p:nvSpPr>
-          <p:cNvPr id="20" name="TextBox 19"/>
+          <p:cNvPr id="23" name="TextBox 22"/>
           <p:cNvSpPr txBox="1"/>
           <p:nvPr/>
         </p:nvSpPr>
         <p:spPr>
           <a:xfrm>
-            <a:off x="329184" y="3959352"/>
+            <a:off x="329184" y="4169664"/>
             <a:ext cx="3505200" cy="822960"/>
           </a:xfrm>
           <a:prstGeom prst="rect">
@@ -4169,7 +4292,7 @@
       </p:sp>
       <p:sp>
         <p:nvSpPr>
-          <p:cNvPr id="21" name="Rounded Rectangle 20"/>
+          <p:cNvPr id="24" name="Rounded Rectangle 23"/>
           <p:cNvSpPr/>
           <p:nvPr/>
         </p:nvSpPr>
@@ -4217,7 +4340,7 @@
       </p:sp>
       <p:sp>
         <p:nvSpPr>
-          <p:cNvPr id="22" name="Rounded Rectangle 21"/>
+          <p:cNvPr id="25" name="Rounded Rectangle 24"/>
           <p:cNvSpPr/>
           <p:nvPr/>
         </p:nvSpPr>
@@ -4263,7 +4386,7 @@
       </p:sp>
       <p:sp>
         <p:nvSpPr>
-          <p:cNvPr id="23" name="TextBox 22"/>
+          <p:cNvPr id="26" name="TextBox 25"/>
           <p:cNvSpPr txBox="1"/>
           <p:nvPr/>
         </p:nvSpPr>
@@ -4304,7 +4427,7 @@
       </p:sp>
       <p:sp>
         <p:nvSpPr>
-          <p:cNvPr id="24" name="TextBox 23"/>
+          <p:cNvPr id="27" name="TextBox 26"/>
           <p:cNvSpPr txBox="1"/>
           <p:nvPr/>
         </p:nvSpPr>
@@ -4345,7 +4468,7 @@
       </p:sp>
       <p:sp>
         <p:nvSpPr>
-          <p:cNvPr id="25" name="Rectangle 24"/>
+          <p:cNvPr id="28" name="Rectangle 27"/>
           <p:cNvSpPr/>
           <p:nvPr/>
         </p:nvSpPr>
@@ -4391,7 +4514,7 @@
       </p:sp>
       <p:sp>
         <p:nvSpPr>
-          <p:cNvPr id="26" name="Rectangle 25"/>
+          <p:cNvPr id="29" name="Rectangle 28"/>
           <p:cNvSpPr/>
           <p:nvPr/>
         </p:nvSpPr>
@@ -4437,7 +4560,7 @@
       </p:sp>
       <p:sp>
         <p:nvSpPr>
-          <p:cNvPr id="27" name="Rectangle 26"/>
+          <p:cNvPr id="30" name="Rectangle 29"/>
           <p:cNvSpPr/>
           <p:nvPr/>
         </p:nvSpPr>
@@ -4483,7 +4606,7 @@
       </p:sp>
       <p:sp>
         <p:nvSpPr>
-          <p:cNvPr id="28" name="TextBox 27"/>
+          <p:cNvPr id="31" name="TextBox 30"/>
           <p:cNvSpPr txBox="1"/>
           <p:nvPr/>
         </p:nvSpPr>
@@ -4524,7 +4647,7 @@
       </p:sp>
       <p:sp>
         <p:nvSpPr>
-          <p:cNvPr id="29" name="TextBox 28"/>
+          <p:cNvPr id="32" name="TextBox 31"/>
           <p:cNvSpPr txBox="1"/>
           <p:nvPr/>
         </p:nvSpPr>
@@ -4565,7 +4688,7 @@
       </p:sp>
       <p:sp>
         <p:nvSpPr>
-          <p:cNvPr id="30" name="TextBox 29"/>
+          <p:cNvPr id="33" name="TextBox 32"/>
           <p:cNvSpPr txBox="1"/>
           <p:nvPr/>
         </p:nvSpPr>
@@ -4606,7 +4729,7 @@
       </p:sp>
       <p:sp>
         <p:nvSpPr>
-          <p:cNvPr id="31" name="TextBox 30"/>
+          <p:cNvPr id="34" name="TextBox 33"/>
           <p:cNvSpPr txBox="1"/>
           <p:nvPr/>
         </p:nvSpPr>
@@ -4647,7 +4770,7 @@
       </p:sp>
       <p:sp>
         <p:nvSpPr>
-          <p:cNvPr id="32" name="TextBox 31"/>
+          <p:cNvPr id="35" name="TextBox 34"/>
           <p:cNvSpPr txBox="1"/>
           <p:nvPr/>
         </p:nvSpPr>
@@ -4717,14 +4840,14 @@
       </p:sp>
       <p:sp>
         <p:nvSpPr>
-          <p:cNvPr id="33" name="Rounded Rectangle 32"/>
+          <p:cNvPr id="36" name="Rounded Rectangle 35"/>
           <p:cNvSpPr/>
           <p:nvPr/>
         </p:nvSpPr>
         <p:spPr>
           <a:xfrm>
             <a:off x="4200144" y="3227832"/>
-            <a:ext cx="3761232" cy="1691640"/>
+            <a:ext cx="3761232" cy="1874519"/>
           </a:xfrm>
           <a:prstGeom prst="roundRect">
             <a:avLst>
@@ -4765,7 +4888,7 @@
       </p:sp>
       <p:sp>
         <p:nvSpPr>
-          <p:cNvPr id="34" name="Rounded Rectangle 33"/>
+          <p:cNvPr id="37" name="Rounded Rectangle 36"/>
           <p:cNvSpPr/>
           <p:nvPr/>
         </p:nvSpPr>
@@ -4811,7 +4934,7 @@
       </p:sp>
       <p:sp>
         <p:nvSpPr>
-          <p:cNvPr id="35" name="TextBox 34"/>
+          <p:cNvPr id="38" name="TextBox 37"/>
           <p:cNvSpPr txBox="1"/>
           <p:nvPr/>
         </p:nvSpPr>
@@ -4852,7 +4975,7 @@
       </p:sp>
       <p:sp>
         <p:nvSpPr>
-          <p:cNvPr id="36" name="TextBox 35"/>
+          <p:cNvPr id="39" name="TextBox 38"/>
           <p:cNvSpPr txBox="1"/>
           <p:nvPr/>
         </p:nvSpPr>
@@ -4893,7 +5016,7 @@
       </p:sp>
       <p:pic>
         <p:nvPicPr>
-          <p:cNvPr id="37" name="Picture 36" descr="bge_baai.png"/>
+          <p:cNvPr id="40" name="Picture 39" descr="bge_baai.png"/>
           <p:cNvPicPr>
             <a:picLocks noChangeAspect="1"/>
           </p:cNvPicPr>
@@ -4907,17 +5030,58 @@
         </p:blipFill>
         <p:spPr>
           <a:xfrm>
-            <a:off x="4840224" y="3977639"/>
-            <a:ext cx="457200" cy="457200"/>
+            <a:off x="4748784" y="3959352"/>
+            <a:ext cx="438912" cy="438912"/>
           </a:xfrm>
           <a:prstGeom prst="rect">
             <a:avLst/>
           </a:prstGeom>
         </p:spPr>
       </p:pic>
+      <p:sp>
+        <p:nvSpPr>
+          <p:cNvPr id="41" name="TextBox 40"/>
+          <p:cNvSpPr txBox="1"/>
+          <p:nvPr/>
+        </p:nvSpPr>
+        <p:spPr>
+          <a:xfrm>
+            <a:off x="4556760" y="4416552"/>
+            <a:ext cx="822960" cy="201168"/>
+          </a:xfrm>
+          <a:prstGeom prst="rect">
+            <a:avLst/>
+          </a:prstGeom>
+          <a:noFill/>
+        </p:spPr>
+        <p:txBody>
+          <a:bodyPr wrap="square" anchor="t" lIns="38100" rIns="38100" tIns="25400" bIns="25400">
+            <a:spAutoFit/>
+          </a:bodyPr>
+          <a:lstStyle/>
+          <a:p>
+            <a:pPr algn="ctr">
+              <a:lnSpc>
+                <a:spcPct val="110000"/>
+              </a:lnSpc>
+            </a:pPr>
+            <a:r>
+              <a:rPr sz="800" b="0" i="1">
+                <a:solidFill>
+                  <a:srgbClr val="555555"/>
+                </a:solidFill>
+                <a:latin typeface="Calibri"/>
+                <a:ea typeface="Calibri"/>
+                <a:cs typeface="Calibri"/>
+              </a:rPr>
+              <a:t>BGE-M3</a:t>
+            </a:r>
+          </a:p>
+        </p:txBody>
+      </p:sp>
       <p:pic>
         <p:nvPicPr>
-          <p:cNvPr id="38" name="Picture 37" descr="me5_ms.png"/>
+          <p:cNvPr id="42" name="Picture 41" descr="me5_ms.png"/>
           <p:cNvPicPr>
             <a:picLocks noChangeAspect="1"/>
           </p:cNvPicPr>
@@ -4931,17 +5095,58 @@
         </p:blipFill>
         <p:spPr>
           <a:xfrm>
-            <a:off x="5891784" y="3977639"/>
-            <a:ext cx="457200" cy="457200"/>
+            <a:off x="5754624" y="3959352"/>
+            <a:ext cx="438912" cy="438912"/>
           </a:xfrm>
           <a:prstGeom prst="rect">
             <a:avLst/>
           </a:prstGeom>
         </p:spPr>
       </p:pic>
+      <p:sp>
+        <p:nvSpPr>
+          <p:cNvPr id="43" name="TextBox 42"/>
+          <p:cNvSpPr txBox="1"/>
+          <p:nvPr/>
+        </p:nvSpPr>
+        <p:spPr>
+          <a:xfrm>
+            <a:off x="5562600" y="4416552"/>
+            <a:ext cx="822960" cy="201168"/>
+          </a:xfrm>
+          <a:prstGeom prst="rect">
+            <a:avLst/>
+          </a:prstGeom>
+          <a:noFill/>
+        </p:spPr>
+        <p:txBody>
+          <a:bodyPr wrap="square" anchor="t" lIns="38100" rIns="38100" tIns="25400" bIns="25400">
+            <a:spAutoFit/>
+          </a:bodyPr>
+          <a:lstStyle/>
+          <a:p>
+            <a:pPr algn="ctr">
+              <a:lnSpc>
+                <a:spcPct val="110000"/>
+              </a:lnSpc>
+            </a:pPr>
+            <a:r>
+              <a:rPr sz="800" b="0" i="1">
+                <a:solidFill>
+                  <a:srgbClr val="555555"/>
+                </a:solidFill>
+                <a:latin typeface="Calibri"/>
+                <a:ea typeface="Calibri"/>
+                <a:cs typeface="Calibri"/>
+              </a:rPr>
+              <a:t>mE5</a:t>
+            </a:r>
+          </a:p>
+        </p:txBody>
+      </p:sp>
       <p:pic>
         <p:nvPicPr>
-          <p:cNvPr id="39" name="Picture 38" descr="qwen.png"/>
+          <p:cNvPr id="44" name="Picture 43" descr="qwen.png"/>
           <p:cNvPicPr>
             <a:picLocks noChangeAspect="1"/>
           </p:cNvPicPr>
@@ -4955,8 +5160,8 @@
         </p:blipFill>
         <p:spPr>
           <a:xfrm>
-            <a:off x="6806184" y="3977639"/>
-            <a:ext cx="457200" cy="457200"/>
+            <a:off x="6760464" y="3959352"/>
+            <a:ext cx="438912" cy="438912"/>
           </a:xfrm>
           <a:prstGeom prst="rect">
             <a:avLst/>
@@ -4965,14 +5170,14 @@
       </p:pic>
       <p:sp>
         <p:nvSpPr>
-          <p:cNvPr id="40" name="TextBox 39"/>
+          <p:cNvPr id="45" name="TextBox 44"/>
           <p:cNvSpPr txBox="1"/>
           <p:nvPr/>
         </p:nvSpPr>
         <p:spPr>
           <a:xfrm>
-            <a:off x="4291584" y="4453128"/>
-            <a:ext cx="3578352" cy="219456"/>
+            <a:off x="6568440" y="4416552"/>
+            <a:ext cx="822960" cy="201168"/>
           </a:xfrm>
           <a:prstGeom prst="rect">
             <a:avLst/>
@@ -4991,7 +5196,7 @@
               </a:lnSpc>
             </a:pPr>
             <a:r>
-              <a:rPr sz="850" b="0" i="1">
+              <a:rPr sz="800" b="0" i="1">
                 <a:solidFill>
                   <a:srgbClr val="555555"/>
                 </a:solidFill>
@@ -4999,21 +5204,21 @@
                 <a:ea typeface="Calibri"/>
                 <a:cs typeface="Calibri"/>
               </a:rPr>
-              <a:t>BGE-M3 · mE5 · Qwen3-Emb</a:t>
-            </a:r>
-          </a:p>
-        </p:txBody>
-      </p:sp>
-      <p:sp>
-        <p:nvSpPr>
-          <p:cNvPr id="41" name="TextBox 40"/>
+              <a:t>Qwen3-Emb</a:t>
+            </a:r>
+          </a:p>
+        </p:txBody>
+      </p:sp>
+      <p:sp>
+        <p:nvSpPr>
+          <p:cNvPr id="46" name="TextBox 45"/>
           <p:cNvSpPr txBox="1"/>
           <p:nvPr/>
         </p:nvSpPr>
         <p:spPr>
           <a:xfrm>
-            <a:off x="4309872" y="4553712"/>
-            <a:ext cx="3541776" cy="310896"/>
+            <a:off x="4309872" y="4773168"/>
+            <a:ext cx="3541776" cy="292608"/>
           </a:xfrm>
           <a:prstGeom prst="rect">
             <a:avLst/>
@@ -5047,7 +5252,7 @@
       </p:sp>
       <p:sp>
         <p:nvSpPr>
-          <p:cNvPr id="42" name="Rounded Rectangle 41"/>
+          <p:cNvPr id="47" name="Rounded Rectangle 46"/>
           <p:cNvSpPr/>
           <p:nvPr/>
         </p:nvSpPr>
@@ -5095,7 +5300,7 @@
       </p:sp>
       <p:sp>
         <p:nvSpPr>
-          <p:cNvPr id="43" name="Rounded Rectangle 42"/>
+          <p:cNvPr id="48" name="Rounded Rectangle 47"/>
           <p:cNvSpPr/>
           <p:nvPr/>
         </p:nvSpPr>
@@ -5141,7 +5346,7 @@
       </p:sp>
       <p:sp>
         <p:nvSpPr>
-          <p:cNvPr id="44" name="TextBox 43"/>
+          <p:cNvPr id="49" name="TextBox 48"/>
           <p:cNvSpPr txBox="1"/>
           <p:nvPr/>
         </p:nvSpPr>
@@ -5182,7 +5387,7 @@
       </p:sp>
       <p:sp>
         <p:nvSpPr>
-          <p:cNvPr id="45" name="TextBox 44"/>
+          <p:cNvPr id="50" name="TextBox 49"/>
           <p:cNvSpPr txBox="1"/>
           <p:nvPr/>
         </p:nvSpPr>
@@ -5223,7 +5428,7 @@
       </p:sp>
       <p:sp>
         <p:nvSpPr>
-          <p:cNvPr id="46" name="Rounded Rectangle 45"/>
+          <p:cNvPr id="51" name="Rounded Rectangle 50"/>
           <p:cNvSpPr/>
           <p:nvPr/>
         </p:nvSpPr>
@@ -5271,7 +5476,7 @@
       </p:sp>
       <p:sp>
         <p:nvSpPr>
-          <p:cNvPr id="47" name="TextBox 46"/>
+          <p:cNvPr id="52" name="TextBox 51"/>
           <p:cNvSpPr txBox="1"/>
           <p:nvPr/>
         </p:nvSpPr>
@@ -5312,7 +5517,7 @@
       </p:sp>
       <p:sp>
         <p:nvSpPr>
-          <p:cNvPr id="48" name="TextBox 47"/>
+          <p:cNvPr id="53" name="TextBox 52"/>
           <p:cNvSpPr txBox="1"/>
           <p:nvPr/>
         </p:nvSpPr>
@@ -5353,7 +5558,7 @@
       </p:sp>
       <p:sp>
         <p:nvSpPr>
-          <p:cNvPr id="49" name="Rounded Rectangle 48"/>
+          <p:cNvPr id="54" name="Rounded Rectangle 53"/>
           <p:cNvSpPr/>
           <p:nvPr/>
         </p:nvSpPr>
@@ -5401,7 +5606,7 @@
       </p:sp>
       <p:sp>
         <p:nvSpPr>
-          <p:cNvPr id="50" name="TextBox 49"/>
+          <p:cNvPr id="55" name="TextBox 54"/>
           <p:cNvSpPr txBox="1"/>
           <p:nvPr/>
         </p:nvSpPr>
@@ -5442,7 +5647,7 @@
       </p:sp>
       <p:sp>
         <p:nvSpPr>
-          <p:cNvPr id="51" name="Rounded Rectangle 50"/>
+          <p:cNvPr id="56" name="Rounded Rectangle 55"/>
           <p:cNvSpPr/>
           <p:nvPr/>
         </p:nvSpPr>
@@ -5490,7 +5695,7 @@
       </p:sp>
       <p:sp>
         <p:nvSpPr>
-          <p:cNvPr id="52" name="Rounded Rectangle 51"/>
+          <p:cNvPr id="57" name="Rounded Rectangle 56"/>
           <p:cNvSpPr/>
           <p:nvPr/>
         </p:nvSpPr>
@@ -5536,7 +5741,7 @@
       </p:sp>
       <p:sp>
         <p:nvSpPr>
-          <p:cNvPr id="53" name="TextBox 52"/>
+          <p:cNvPr id="58" name="TextBox 57"/>
           <p:cNvSpPr txBox="1"/>
           <p:nvPr/>
         </p:nvSpPr>
@@ -5577,7 +5782,7 @@
       </p:sp>
       <p:sp>
         <p:nvSpPr>
-          <p:cNvPr id="54" name="TextBox 53"/>
+          <p:cNvPr id="59" name="TextBox 58"/>
           <p:cNvSpPr txBox="1"/>
           <p:nvPr/>
         </p:nvSpPr>
@@ -5618,7 +5823,7 @@
       </p:sp>
       <p:sp>
         <p:nvSpPr>
-          <p:cNvPr id="55" name="TextBox 54"/>
+          <p:cNvPr id="60" name="TextBox 59"/>
           <p:cNvSpPr txBox="1"/>
           <p:nvPr/>
         </p:nvSpPr>
@@ -5659,7 +5864,7 @@
       </p:sp>
       <p:sp>
         <p:nvSpPr>
-          <p:cNvPr id="56" name="Rectangle 55"/>
+          <p:cNvPr id="61" name="Rectangle 60"/>
           <p:cNvSpPr/>
           <p:nvPr/>
         </p:nvSpPr>
@@ -5705,7 +5910,7 @@
       </p:sp>
       <p:sp>
         <p:nvSpPr>
-          <p:cNvPr id="57" name="TextBox 56"/>
+          <p:cNvPr id="62" name="TextBox 61"/>
           <p:cNvSpPr txBox="1"/>
           <p:nvPr/>
         </p:nvSpPr>
@@ -5746,7 +5951,7 @@
       </p:sp>
       <p:sp>
         <p:nvSpPr>
-          <p:cNvPr id="58" name="TextBox 57"/>
+          <p:cNvPr id="63" name="TextBox 62"/>
           <p:cNvSpPr txBox="1"/>
           <p:nvPr/>
         </p:nvSpPr>
@@ -5787,7 +5992,7 @@
       </p:sp>
       <p:sp>
         <p:nvSpPr>
-          <p:cNvPr id="59" name="Rectangle 58"/>
+          <p:cNvPr id="64" name="Rectangle 63"/>
           <p:cNvSpPr/>
           <p:nvPr/>
         </p:nvSpPr>
@@ -5833,7 +6038,7 @@
       </p:sp>
       <p:sp>
         <p:nvSpPr>
-          <p:cNvPr id="60" name="TextBox 59"/>
+          <p:cNvPr id="65" name="TextBox 64"/>
           <p:cNvSpPr txBox="1"/>
           <p:nvPr/>
         </p:nvSpPr>
@@ -5874,7 +6079,7 @@
       </p:sp>
       <p:sp>
         <p:nvSpPr>
-          <p:cNvPr id="61" name="TextBox 60"/>
+          <p:cNvPr id="66" name="TextBox 65"/>
           <p:cNvSpPr txBox="1"/>
           <p:nvPr/>
         </p:nvSpPr>
@@ -5933,7 +6138,7 @@
       </p:sp>
       <p:sp>
         <p:nvSpPr>
-          <p:cNvPr id="62" name="Chevron 61"/>
+          <p:cNvPr id="67" name="Chevron 66"/>
           <p:cNvSpPr/>
           <p:nvPr/>
         </p:nvSpPr>
@@ -5977,7 +6182,7 @@
       </p:sp>
       <p:sp>
         <p:nvSpPr>
-          <p:cNvPr id="63" name="Chevron 62"/>
+          <p:cNvPr id="68" name="Chevron 67"/>
           <p:cNvSpPr/>
           <p:nvPr/>
         </p:nvSpPr>

</xml_diff>

<commit_message>
fig: overview C1 — lead with robust 2.8x Hit@1 swing, demote r=-0.81
Align Figure 1 with the paper's reframing (261ea57): the figure was showing
the fragile r=-0.81 prominently but not the robust headline. Now C1's table
'retrieval' column shows actual Hit@1 (MinerU 0.20 vs Prod 0.55), and the
note leads with 'parser choice alone swings Hit@1 by 2.8x' (bold), with
'(anti-correlation r=-0.81, n=5)' demoted to a small hedged line. Also
'0.72 (highest)' -> '0.72 (top)' since Marker ties.
</commit_message>
<xml_diff>
--- a/paper/figures/fig_overview.pptx
+++ b/paper/figures/fig_overview.pptx
@@ -3889,7 +3889,7 @@
         </p:nvGraphicFramePr>
         <p:xfrm>
           <a:off x="384048" y="2478024"/>
-          <a:ext cx="3395470" cy="1554480"/>
+          <a:ext cx="3395469" cy="1554480"/>
         </p:xfrm>
         <a:graphic>
           <a:graphicData uri="http://schemas.openxmlformats.org/drawingml/2006/table">
@@ -3898,10 +3898,10 @@
                 <a:tableStyleId>{5C22544A-7EE6-4342-B048-85BDC9FD1C3A}</a:tableStyleId>
               </a:tblPr>
               <a:tblGrid>
-                <a:gridCol w="950732"/>
-                <a:gridCol w="1177096"/>
-                <a:gridCol w="561384"/>
-                <a:gridCol w="706258"/>
+                <a:gridCol w="968816"/>
+                <a:gridCol w="1245621"/>
+                <a:gridCol w="535155"/>
+                <a:gridCol w="645877"/>
               </a:tblGrid>
               <a:tr h="518160">
                 <a:tc>
@@ -3994,7 +3994,7 @@
                           <a:ea typeface="Calibri"/>
                           <a:cs typeface="Calibri"/>
                         </a:rPr>
-                        <a:t>retrieval</a:t>
+                        <a:t>Hit@1</a:t>
                       </a:r>
                     </a:p>
                   </a:txBody>
@@ -4046,7 +4046,7 @@
                           <a:ea typeface="Calibri"/>
                           <a:cs typeface="Calibri"/>
                         </a:rPr>
-                        <a:t>0.72  (highest)</a:t>
+                        <a:t>0.72  (top)</a:t>
                       </a:r>
                     </a:p>
                   </a:txBody>
@@ -4096,7 +4096,7 @@
                           <a:ea typeface="Calibri"/>
                           <a:cs typeface="Calibri"/>
                         </a:rPr>
-                        <a:t>MISS</a:t>
+                        <a:t>0.20</a:t>
                       </a:r>
                     </a:p>
                   </a:txBody>
@@ -4198,7 +4198,7 @@
                           <a:ea typeface="Calibri"/>
                           <a:cs typeface="Calibri"/>
                         </a:rPr>
-                        <a:t>HIT</a:t>
+                        <a:t>0.55</a:t>
                       </a:r>
                     </a:p>
                   </a:txBody>
@@ -4221,8 +4221,8 @@
         </p:nvSpPr>
         <p:spPr>
           <a:xfrm>
-            <a:off x="329184" y="4169664"/>
-            <a:ext cx="3505200" cy="822960"/>
+            <a:off x="329184" y="4123944"/>
+            <a:ext cx="3505200" cy="868680"/>
           </a:xfrm>
           <a:prstGeom prst="rect">
             <a:avLst/>
@@ -4237,11 +4237,11 @@
           <a:p>
             <a:pPr algn="ctr">
               <a:lnSpc>
-                <a:spcPct val="132000"/>
+                <a:spcPct val="140000"/>
               </a:lnSpc>
             </a:pPr>
             <a:r>
-              <a:rPr sz="950" b="0" i="0">
+              <a:rPr sz="1050" b="0" i="0">
                 <a:solidFill>
                   <a:srgbClr val="202020"/>
                 </a:solidFill>
@@ -4249,17 +4249,28 @@
                 <a:ea typeface="Calibri"/>
                 <a:cs typeface="Calibri"/>
               </a:rPr>
-              <a:t>highest Boundary Clarity, yet worst retrieval:</a:t>
+              <a:t>parser choice alone swings Hit@1 by </a:t>
+            </a:r>
+            <a:r>
+              <a:rPr sz="1250" b="1" i="0">
+                <a:solidFill>
+                  <a:srgbClr val="1F5FA8"/>
+                </a:solidFill>
+                <a:latin typeface="Calibri"/>
+                <a:ea typeface="Calibri"/>
+                <a:cs typeface="Calibri"/>
+              </a:rPr>
+              <a:t>2.8×</a:t>
             </a:r>
           </a:p>
           <a:p>
             <a:pPr algn="ctr">
               <a:lnSpc>
-                <a:spcPct val="132000"/>
+                <a:spcPct val="140000"/>
               </a:lnSpc>
             </a:pPr>
             <a:r>
-              <a:rPr sz="950" b="0" i="0">
+              <a:rPr sz="900" b="0" i="0">
                 <a:solidFill>
                   <a:srgbClr val="202020"/>
                 </a:solidFill>
@@ -4273,19 +4284,19 @@
           <a:p>
             <a:pPr algn="ctr">
               <a:lnSpc>
-                <a:spcPct val="132000"/>
+                <a:spcPct val="140000"/>
               </a:lnSpc>
             </a:pPr>
             <a:r>
-              <a:rPr sz="1050" b="1" i="0">
+              <a:rPr sz="850" b="0" i="1">
                 <a:solidFill>
-                  <a:srgbClr val="8F1B1B"/>
+                  <a:srgbClr val="555555"/>
                 </a:solidFill>
                 <a:latin typeface="Calibri"/>
                 <a:ea typeface="Calibri"/>
                 <a:cs typeface="Calibri"/>
               </a:rPr>
-              <a:t>anti-correlation   r = −0.81</a:t>
+              <a:t>(anti-correlation  r = −0.81,  n = 5)</a:t>
             </a:r>
           </a:p>
         </p:txBody>

</xml_diff>

<commit_message>
fig: overview — exact Prod BC 0.61 (not 'lower'), align all 3 column bottoms
C1 table: give Prod its actual Boundary Clarity (0.61, from the adopted MoC
grid that yields r=-0.81) instead of the asymmetric 'lower'; MinerU 0.72.
Define a shared BOT edge and set each column's last zone height to BOT - its
start, so C1 / C2-C3 / C4 end on exactly the same line (were off by up to
0.2in).
</commit_message>
<xml_diff>
--- a/paper/figures/fig_overview.pptx
+++ b/paper/figures/fig_overview.pptx
@@ -3753,7 +3753,7 @@
         <p:spPr>
           <a:xfrm>
             <a:off x="201168" y="1975104"/>
-            <a:ext cx="3761232" cy="3108960"/>
+            <a:ext cx="3761232" cy="3108959"/>
           </a:xfrm>
           <a:prstGeom prst="roundRect">
             <a:avLst>
@@ -4046,7 +4046,7 @@
                           <a:ea typeface="Calibri"/>
                           <a:cs typeface="Calibri"/>
                         </a:rPr>
-                        <a:t>0.72  (top)</a:t>
+                        <a:t>0.72</a:t>
                       </a:r>
                     </a:p>
                   </a:txBody>
@@ -4148,7 +4148,7 @@
                           <a:ea typeface="Calibri"/>
                           <a:cs typeface="Calibri"/>
                         </a:rPr>
-                        <a:t>lower</a:t>
+                        <a:t>0.61</a:t>
                       </a:r>
                     </a:p>
                   </a:txBody>
@@ -4858,7 +4858,7 @@
         <p:spPr>
           <a:xfrm>
             <a:off x="4200144" y="3227832"/>
-            <a:ext cx="3761232" cy="1874519"/>
+            <a:ext cx="3761232" cy="1856231"/>
           </a:xfrm>
           <a:prstGeom prst="roundRect">
             <a:avLst>
@@ -5228,7 +5228,7 @@
         </p:nvSpPr>
         <p:spPr>
           <a:xfrm>
-            <a:off x="4309872" y="4773168"/>
+            <a:off x="4309872" y="4754879"/>
             <a:ext cx="3541776" cy="292608"/>
           </a:xfrm>
           <a:prstGeom prst="rect">
@@ -5665,7 +5665,7 @@
         <p:spPr>
           <a:xfrm>
             <a:off x="8199120" y="2679192"/>
-            <a:ext cx="3761232" cy="2240280"/>
+            <a:ext cx="3761232" cy="2404871"/>
           </a:xfrm>
           <a:prstGeom prst="roundRect">
             <a:avLst>
@@ -6096,7 +6096,7 @@
         </p:nvSpPr>
         <p:spPr>
           <a:xfrm>
-            <a:off x="8327136" y="4315968"/>
+            <a:off x="8327136" y="4480559"/>
             <a:ext cx="3505200" cy="548640"/>
           </a:xfrm>
           <a:prstGeom prst="rect">

</xml_diff>

<commit_message>
fig: overview C1 — drop confusing 'answer no/yes' column
The 'answer' column (no/yes = is the answer in the parse) was ambiguous as a
header and duplicated C2's coverage story. C1's table is now a clean 3-col
appearance-vs-retrieval contrast: parser | Boundary Clarity | Hit@1 (MinerU
0.72/0.20 vs Prod 0.61/0.55), which shows 'cleaner-looking != better
retrieval' directly. The answer-coverage point stays in C2 where it belongs.
</commit_message>
<xml_diff>
--- a/paper/figures/fig_overview.pptx
+++ b/paper/figures/fig_overview.pptx
@@ -3888,8 +3888,8 @@
           <p:nvPr/>
         </p:nvGraphicFramePr>
         <p:xfrm>
-          <a:off x="384048" y="2478024"/>
-          <a:ext cx="3395469" cy="1554480"/>
+          <a:off x="384048" y="2505456"/>
+          <a:ext cx="3395471" cy="1463040"/>
         </p:xfrm>
         <a:graphic>
           <a:graphicData uri="http://schemas.openxmlformats.org/drawingml/2006/table">
@@ -3898,12 +3898,11 @@
                 <a:tableStyleId>{5C22544A-7EE6-4342-B048-85BDC9FD1C3A}</a:tableStyleId>
               </a:tblPr>
               <a:tblGrid>
-                <a:gridCol w="968816"/>
-                <a:gridCol w="1245621"/>
-                <a:gridCol w="535155"/>
-                <a:gridCol w="645877"/>
+                <a:gridCol w="1033404"/>
+                <a:gridCol w="1427082"/>
+                <a:gridCol w="934985"/>
               </a:tblGrid>
-              <a:tr h="518160">
+              <a:tr h="487680">
                 <a:tc>
                   <a:txBody>
                     <a:bodyPr/>
@@ -3969,31 +3968,6 @@
                           <a:ea typeface="Calibri"/>
                           <a:cs typeface="Calibri"/>
                         </a:rPr>
-                        <a:t>answer</a:t>
-                      </a:r>
-                    </a:p>
-                  </a:txBody>
-                  <a:tcPr anchor="ctr" marL="38100" marR="38100" marT="12700" marB="12700">
-                    <a:solidFill>
-                      <a:srgbClr val="ECECEC"/>
-                    </a:solidFill>
-                  </a:tcPr>
-                </a:tc>
-                <a:tc>
-                  <a:txBody>
-                    <a:bodyPr/>
-                    <a:lstStyle/>
-                    <a:p>
-                      <a:pPr algn="ctr"/>
-                      <a:r>
-                        <a:rPr sz="850" b="1">
-                          <a:solidFill>
-                            <a:srgbClr val="202020"/>
-                          </a:solidFill>
-                          <a:latin typeface="Calibri"/>
-                          <a:ea typeface="Calibri"/>
-                          <a:cs typeface="Calibri"/>
-                        </a:rPr>
                         <a:t>Hit@1</a:t>
                       </a:r>
                     </a:p>
@@ -4005,7 +3979,7 @@
                   </a:tcPr>
                 </a:tc>
               </a:tr>
-              <a:tr h="518160">
+              <a:tr h="487680">
                 <a:tc>
                   <a:txBody>
                     <a:bodyPr/>
@@ -4046,32 +4020,7 @@
                           <a:ea typeface="Calibri"/>
                           <a:cs typeface="Calibri"/>
                         </a:rPr>
-                        <a:t>0.72</a:t>
-                      </a:r>
-                    </a:p>
-                  </a:txBody>
-                  <a:tcPr anchor="ctr" marL="38100" marR="38100" marT="12700" marB="12700">
-                    <a:solidFill>
-                      <a:srgbClr val="F9ECEC"/>
-                    </a:solidFill>
-                  </a:tcPr>
-                </a:tc>
-                <a:tc>
-                  <a:txBody>
-                    <a:bodyPr/>
-                    <a:lstStyle/>
-                    <a:p>
-                      <a:pPr algn="ctr"/>
-                      <a:r>
-                        <a:rPr sz="950" b="1">
-                          <a:solidFill>
-                            <a:srgbClr val="8F1B1B"/>
-                          </a:solidFill>
-                          <a:latin typeface="Calibri"/>
-                          <a:ea typeface="Calibri"/>
-                          <a:cs typeface="Calibri"/>
-                        </a:rPr>
-                        <a:t>no</a:t>
+                        <a:t>0.72  (highest)</a:t>
                       </a:r>
                     </a:p>
                   </a:txBody>
@@ -4107,7 +4056,7 @@
                   </a:tcPr>
                 </a:tc>
               </a:tr>
-              <a:tr h="518160">
+              <a:tr h="487680">
                 <a:tc>
                   <a:txBody>
                     <a:bodyPr/>
@@ -4149,31 +4098,6 @@
                           <a:cs typeface="Calibri"/>
                         </a:rPr>
                         <a:t>0.61</a:t>
-                      </a:r>
-                    </a:p>
-                  </a:txBody>
-                  <a:tcPr anchor="ctr" marL="38100" marR="38100" marT="12700" marB="12700">
-                    <a:solidFill>
-                      <a:srgbClr val="ECF6EC"/>
-                    </a:solidFill>
-                  </a:tcPr>
-                </a:tc>
-                <a:tc>
-                  <a:txBody>
-                    <a:bodyPr/>
-                    <a:lstStyle/>
-                    <a:p>
-                      <a:pPr algn="ctr"/>
-                      <a:r>
-                        <a:rPr sz="950" b="1">
-                          <a:solidFill>
-                            <a:srgbClr val="1A6B1A"/>
-                          </a:solidFill>
-                          <a:latin typeface="Calibri"/>
-                          <a:ea typeface="Calibri"/>
-                          <a:cs typeface="Calibri"/>
-                        </a:rPr>
-                        <a:t>yes</a:t>
                       </a:r>
                     </a:p>
                   </a:txBody>

</xml_diff>

<commit_message>
figure1: C4 "vs" 제거 — 경쟁 프레임 대신 control/reward 역할 라벨
"vs"는 두 방법이 경쟁하는 인상(둘 중 승자)을 줘서 "no evidence of
difference" 결론과 충돌. 기호를 빼고 각 박스에 역할을 명시:
  RADP-Distill (reward-free control) / RADP-DPO (retrieval reward)
"ranked two ways:" + Result의 "no evidence reward beats fidelity
control"과 논리 일관. 6pp·overfull 0 유지.

Co-Authored-By: Claude Fable 5 <noreply@anthropic.com>
</commit_message>
<xml_diff>
--- a/paper/figures/fig_overview.pptx
+++ b/paper/figures/fig_overview.pptx
@@ -5480,8 +5480,8 @@
         </p:nvSpPr>
         <p:spPr>
           <a:xfrm>
-            <a:off x="8946184" y="1499616"/>
-            <a:ext cx="2831287" cy="384048"/>
+            <a:off x="8946184" y="1554480"/>
+            <a:ext cx="2831287" cy="402336"/>
           </a:xfrm>
           <a:prstGeom prst="roundRect">
             <a:avLst>
@@ -5528,8 +5528,8 @@
         </p:nvSpPr>
         <p:spPr>
           <a:xfrm>
-            <a:off x="8964472" y="1499616"/>
-            <a:ext cx="2794711" cy="384048"/>
+            <a:off x="8964472" y="1554480"/>
+            <a:ext cx="2794711" cy="402336"/>
           </a:xfrm>
           <a:prstGeom prst="rect">
             <a:avLst/>
@@ -5544,11 +5544,11 @@
           <a:p>
             <a:pPr algn="l">
               <a:lnSpc>
-                <a:spcPct val="110000"/>
+                <a:spcPct val="105000"/>
               </a:lnSpc>
             </a:pPr>
             <a:r>
-              <a:rPr sz="950" b="1" i="0">
+              <a:rPr sz="930" b="1" i="0">
                 <a:solidFill>
                   <a:srgbClr val="1A6B1A"/>
                 </a:solidFill>
@@ -5559,59 +5559,36 @@
               <a:t>RADP-Distill — edit-distance → ref</a:t>
             </a:r>
           </a:p>
-        </p:txBody>
-      </p:sp>
-      <p:sp>
-        <p:nvSpPr>
-          <p:cNvPr id="55" name="TextBox 54"/>
-          <p:cNvSpPr txBox="1"/>
-          <p:nvPr/>
-        </p:nvSpPr>
-        <p:spPr>
-          <a:xfrm>
-            <a:off x="8763304" y="1901952"/>
-            <a:ext cx="3197047" cy="182880"/>
-          </a:xfrm>
-          <a:prstGeom prst="rect">
-            <a:avLst/>
-          </a:prstGeom>
-          <a:noFill/>
-        </p:spPr>
-        <p:txBody>
-          <a:bodyPr wrap="square" anchor="t" lIns="38100" rIns="38100" tIns="25400" bIns="25400">
-            <a:spAutoFit/>
-          </a:bodyPr>
-          <a:lstStyle/>
-          <a:p>
-            <a:pPr algn="ctr">
+          <a:p>
+            <a:pPr algn="l">
               <a:lnSpc>
-                <a:spcPct val="110000"/>
+                <a:spcPct val="105000"/>
               </a:lnSpc>
             </a:pPr>
             <a:r>
-              <a:rPr sz="1100" b="1" i="0">
-                <a:solidFill>
-                  <a:srgbClr val="202020"/>
+              <a:rPr sz="780" b="0" i="1">
+                <a:solidFill>
+                  <a:srgbClr val="555555"/>
                 </a:solidFill>
                 <a:latin typeface="Calibri"/>
                 <a:ea typeface="Calibri"/>
                 <a:cs typeface="Calibri"/>
               </a:rPr>
-              <a:t>vs</a:t>
-            </a:r>
-          </a:p>
-        </p:txBody>
-      </p:sp>
-      <p:sp>
-        <p:nvSpPr>
-          <p:cNvPr id="56" name="Rounded Rectangle 55"/>
+              <a:t>(reward-free control)</a:t>
+            </a:r>
+          </a:p>
+        </p:txBody>
+      </p:sp>
+      <p:sp>
+        <p:nvSpPr>
+          <p:cNvPr id="55" name="Rounded Rectangle 54"/>
           <p:cNvSpPr/>
           <p:nvPr/>
         </p:nvSpPr>
         <p:spPr>
           <a:xfrm>
-            <a:off x="8946184" y="2103120"/>
-            <a:ext cx="2831287" cy="384048"/>
+            <a:off x="8946184" y="2048255"/>
+            <a:ext cx="2831287" cy="402336"/>
           </a:xfrm>
           <a:prstGeom prst="roundRect">
             <a:avLst>
@@ -5652,14 +5629,14 @@
       </p:sp>
       <p:sp>
         <p:nvSpPr>
-          <p:cNvPr id="57" name="TextBox 56"/>
+          <p:cNvPr id="56" name="TextBox 55"/>
           <p:cNvSpPr txBox="1"/>
           <p:nvPr/>
         </p:nvSpPr>
         <p:spPr>
           <a:xfrm>
-            <a:off x="8964472" y="2103120"/>
-            <a:ext cx="2794711" cy="384048"/>
+            <a:off x="8964472" y="2048255"/>
+            <a:ext cx="2794711" cy="402336"/>
           </a:xfrm>
           <a:prstGeom prst="rect">
             <a:avLst/>
@@ -5674,11 +5651,11 @@
           <a:p>
             <a:pPr algn="l">
               <a:lnSpc>
-                <a:spcPct val="110000"/>
+                <a:spcPct val="105000"/>
               </a:lnSpc>
             </a:pPr>
             <a:r>
-              <a:rPr sz="950" b="1" i="0">
+              <a:rPr sz="930" b="1" i="0">
                 <a:solidFill>
                   <a:srgbClr val="9A5A00"/>
                 </a:solidFill>
@@ -5689,11 +5666,29 @@
               <a:t>RADP-DPO — page-local RCPS</a:t>
             </a:r>
           </a:p>
-        </p:txBody>
-      </p:sp>
-      <p:sp>
-        <p:nvSpPr>
-          <p:cNvPr id="58" name="Rounded Rectangle 57"/>
+          <a:p>
+            <a:pPr algn="l">
+              <a:lnSpc>
+                <a:spcPct val="105000"/>
+              </a:lnSpc>
+            </a:pPr>
+            <a:r>
+              <a:rPr sz="780" b="0" i="1">
+                <a:solidFill>
+                  <a:srgbClr val="555555"/>
+                </a:solidFill>
+                <a:latin typeface="Calibri"/>
+                <a:ea typeface="Calibri"/>
+                <a:cs typeface="Calibri"/>
+              </a:rPr>
+              <a:t>(retrieval reward)</a:t>
+            </a:r>
+          </a:p>
+        </p:txBody>
+      </p:sp>
+      <p:sp>
+        <p:nvSpPr>
+          <p:cNvPr id="57" name="Rounded Rectangle 56"/>
           <p:cNvSpPr/>
           <p:nvPr/>
         </p:nvSpPr>
@@ -5741,7 +5736,7 @@
       </p:sp>
       <p:sp>
         <p:nvSpPr>
-          <p:cNvPr id="59" name="Rounded Rectangle 58"/>
+          <p:cNvPr id="58" name="Rounded Rectangle 57"/>
           <p:cNvSpPr/>
           <p:nvPr/>
         </p:nvSpPr>
@@ -5787,7 +5782,7 @@
       </p:sp>
       <p:sp>
         <p:nvSpPr>
-          <p:cNvPr id="60" name="TextBox 59"/>
+          <p:cNvPr id="59" name="TextBox 58"/>
           <p:cNvSpPr txBox="1"/>
           <p:nvPr/>
         </p:nvSpPr>
@@ -5828,7 +5823,7 @@
       </p:sp>
       <p:sp>
         <p:nvSpPr>
-          <p:cNvPr id="61" name="TextBox 60"/>
+          <p:cNvPr id="60" name="TextBox 59"/>
           <p:cNvSpPr txBox="1"/>
           <p:nvPr/>
         </p:nvSpPr>
@@ -5869,7 +5864,7 @@
       </p:sp>
       <p:sp>
         <p:nvSpPr>
-          <p:cNvPr id="62" name="TextBox 61"/>
+          <p:cNvPr id="61" name="TextBox 60"/>
           <p:cNvSpPr txBox="1"/>
           <p:nvPr/>
         </p:nvSpPr>
@@ -5910,7 +5905,7 @@
       </p:sp>
       <p:sp>
         <p:nvSpPr>
-          <p:cNvPr id="63" name="Rectangle 62"/>
+          <p:cNvPr id="62" name="Rectangle 61"/>
           <p:cNvSpPr/>
           <p:nvPr/>
         </p:nvSpPr>
@@ -5956,7 +5951,7 @@
       </p:sp>
       <p:sp>
         <p:nvSpPr>
-          <p:cNvPr id="64" name="TextBox 63"/>
+          <p:cNvPr id="63" name="TextBox 62"/>
           <p:cNvSpPr txBox="1"/>
           <p:nvPr/>
         </p:nvSpPr>
@@ -5997,7 +5992,7 @@
       </p:sp>
       <p:sp>
         <p:nvSpPr>
-          <p:cNvPr id="65" name="TextBox 64"/>
+          <p:cNvPr id="64" name="TextBox 63"/>
           <p:cNvSpPr txBox="1"/>
           <p:nvPr/>
         </p:nvSpPr>
@@ -6038,7 +6033,7 @@
       </p:sp>
       <p:sp>
         <p:nvSpPr>
-          <p:cNvPr id="66" name="Rectangle 65"/>
+          <p:cNvPr id="65" name="Rectangle 64"/>
           <p:cNvSpPr/>
           <p:nvPr/>
         </p:nvSpPr>
@@ -6084,7 +6079,7 @@
       </p:sp>
       <p:sp>
         <p:nvSpPr>
-          <p:cNvPr id="67" name="TextBox 66"/>
+          <p:cNvPr id="66" name="TextBox 65"/>
           <p:cNvSpPr txBox="1"/>
           <p:nvPr/>
         </p:nvSpPr>
@@ -6125,7 +6120,7 @@
       </p:sp>
       <p:sp>
         <p:nvSpPr>
-          <p:cNvPr id="68" name="TextBox 67"/>
+          <p:cNvPr id="67" name="TextBox 66"/>
           <p:cNvSpPr txBox="1"/>
           <p:nvPr/>
         </p:nvSpPr>
@@ -6184,7 +6179,7 @@
       </p:sp>
       <p:sp>
         <p:nvSpPr>
-          <p:cNvPr id="69" name="Chevron 68"/>
+          <p:cNvPr id="68" name="Chevron 67"/>
           <p:cNvSpPr/>
           <p:nvPr/>
         </p:nvSpPr>
@@ -6228,7 +6223,7 @@
       </p:sp>
       <p:sp>
         <p:nvSpPr>
-          <p:cNvPr id="70" name="Chevron 69"/>
+          <p:cNvPr id="69" name="Chevron 68"/>
           <p:cNvSpPr/>
           <p:nvPr/>
         </p:nvSpPr>

</xml_diff>